<commit_message>
Add the monitoring/visualisation panel slide to the PPTX presentation
Append a "Síntese visual — Painel de monitoramento e visualizações" slide
(slide 26) to Apresentacao_BRUMS_HIIT.pptx, reusing the deck's design:
eyebrow + Cambria title, the four-panel figure (gauge, radar, daily
monitoring, 4D bubble) on the left, four colour-coded description cards on
the right, a takeaway bar and footer. Added a reproducible, idempotent
generator (add_monitoramento_slide.py) that builds the slide from
figuras/monitoramento_viz.png. Deck validates clean.

Co-Authored-By: Claude Opus 4.8 <noreply@anthropic.com>
Claude-Session: https://claude.ai/code/session_0157sZ1CmW4MRSmx6a9GoYrN
</commit_message>
<xml_diff>
--- a/auditoria_brums_hiit/tese/Apresentacao_BRUMS_HIIT.pptx
+++ b/auditoria_brums_hiit/tese/Apresentacao_BRUMS_HIIT.pptx
@@ -30,6 +30,7 @@
     <p:sldId id="278" r:id="rId24"/>
     <p:sldId id="279" r:id="rId25"/>
     <p:sldId id="280" r:id="rId26"/>
+    <p:sldId id="281" r:id="rId32"/>
   </p:sldIdLst>
   <p:notesMasterIdLst>
     <p:notesMasterId r:id="rId27"/>
@@ -3428,6 +3429,10 @@
             </a:outerShdw>
           </a:effectLst>
         </p:spPr>
+        <p:txBody>
+          <a:bodyPr/>
+          <a:p/>
+        </p:txBody>
       </p:sp>
       <p:sp>
         <p:nvSpPr>
@@ -3540,6 +3545,10 @@
             </a:outerShdw>
           </a:effectLst>
         </p:spPr>
+        <p:txBody>
+          <a:bodyPr/>
+          <a:p/>
+        </p:txBody>
       </p:sp>
       <p:sp>
         <p:nvSpPr>
@@ -3652,6 +3661,10 @@
             </a:outerShdw>
           </a:effectLst>
         </p:spPr>
+        <p:txBody>
+          <a:bodyPr/>
+          <a:p/>
+        </p:txBody>
       </p:sp>
       <p:sp>
         <p:nvSpPr>
@@ -3764,6 +3777,10 @@
             </a:outerShdw>
           </a:effectLst>
         </p:spPr>
+        <p:txBody>
+          <a:bodyPr/>
+          <a:p/>
+        </p:txBody>
       </p:sp>
       <p:sp>
         <p:nvSpPr>
@@ -3876,6 +3893,10 @@
             </a:outerShdw>
           </a:effectLst>
         </p:spPr>
+        <p:txBody>
+          <a:bodyPr/>
+          <a:p/>
+        </p:txBody>
       </p:sp>
       <p:sp>
         <p:nvSpPr>
@@ -4345,6 +4366,10 @@
             </a:outerShdw>
           </a:effectLst>
         </p:spPr>
+        <p:txBody>
+          <a:bodyPr/>
+          <a:p/>
+        </p:txBody>
       </p:sp>
       <p:sp>
         <p:nvSpPr>
@@ -4559,6 +4584,10 @@
             </a:outerShdw>
           </a:effectLst>
         </p:spPr>
+        <p:txBody>
+          <a:bodyPr/>
+          <a:p/>
+        </p:txBody>
       </p:sp>
       <p:sp>
         <p:nvSpPr>
@@ -4851,6 +4880,10 @@
             </a:outerShdw>
           </a:effectLst>
         </p:spPr>
+        <p:txBody>
+          <a:bodyPr/>
+          <a:p/>
+        </p:txBody>
       </p:sp>
       <p:sp>
         <p:nvSpPr>
@@ -5005,6 +5038,10 @@
             </a:outerShdw>
           </a:effectLst>
         </p:spPr>
+        <p:txBody>
+          <a:bodyPr/>
+          <a:p/>
+        </p:txBody>
       </p:sp>
       <p:sp>
         <p:nvSpPr>
@@ -5336,6 +5373,10 @@
             </a:outerShdw>
           </a:effectLst>
         </p:spPr>
+        <p:txBody>
+          <a:bodyPr/>
+          <a:p/>
+        </p:txBody>
       </p:sp>
       <p:sp>
         <p:nvSpPr>
@@ -5451,6 +5492,10 @@
             </a:outerShdw>
           </a:effectLst>
         </p:spPr>
+        <p:txBody>
+          <a:bodyPr/>
+          <a:p/>
+        </p:txBody>
       </p:sp>
       <p:sp>
         <p:nvSpPr>
@@ -5566,6 +5611,10 @@
             </a:outerShdw>
           </a:effectLst>
         </p:spPr>
+        <p:txBody>
+          <a:bodyPr/>
+          <a:p/>
+        </p:txBody>
       </p:sp>
       <p:sp>
         <p:nvSpPr>
@@ -5681,6 +5730,10 @@
             </a:outerShdw>
           </a:effectLst>
         </p:spPr>
+        <p:txBody>
+          <a:bodyPr/>
+          <a:p/>
+        </p:txBody>
       </p:sp>
       <p:sp>
         <p:nvSpPr>
@@ -5949,6 +6002,10 @@
             </a:outerShdw>
           </a:effectLst>
         </p:spPr>
+        <p:txBody>
+          <a:bodyPr/>
+          <a:p/>
+        </p:txBody>
       </p:sp>
       <p:sp>
         <p:nvSpPr>
@@ -6103,6 +6160,10 @@
             </a:outerShdw>
           </a:effectLst>
         </p:spPr>
+        <p:txBody>
+          <a:bodyPr/>
+          <a:p/>
+        </p:txBody>
       </p:sp>
       <p:sp>
         <p:nvSpPr>
@@ -6257,6 +6318,10 @@
             </a:outerShdw>
           </a:effectLst>
         </p:spPr>
+        <p:txBody>
+          <a:bodyPr/>
+          <a:p/>
+        </p:txBody>
       </p:sp>
       <p:sp>
         <p:nvSpPr>
@@ -6411,6 +6476,10 @@
             </a:outerShdw>
           </a:effectLst>
         </p:spPr>
+        <p:txBody>
+          <a:bodyPr/>
+          <a:p/>
+        </p:txBody>
       </p:sp>
       <p:sp>
         <p:nvSpPr>
@@ -6891,6 +6960,10 @@
             </a:outerShdw>
           </a:effectLst>
         </p:spPr>
+        <p:txBody>
+          <a:bodyPr/>
+          <a:p/>
+        </p:txBody>
       </p:sp>
       <p:sp>
         <p:nvSpPr>
@@ -7006,6 +7079,10 @@
             </a:outerShdw>
           </a:effectLst>
         </p:spPr>
+        <p:txBody>
+          <a:bodyPr/>
+          <a:p/>
+        </p:txBody>
       </p:sp>
       <p:sp>
         <p:nvSpPr>
@@ -7121,6 +7198,10 @@
             </a:outerShdw>
           </a:effectLst>
         </p:spPr>
+        <p:txBody>
+          <a:bodyPr/>
+          <a:p/>
+        </p:txBody>
       </p:sp>
       <p:sp>
         <p:nvSpPr>
@@ -7389,6 +7470,10 @@
             </a:outerShdw>
           </a:effectLst>
         </p:spPr>
+        <p:txBody>
+          <a:bodyPr/>
+          <a:p/>
+        </p:txBody>
       </p:sp>
       <p:sp>
         <p:nvSpPr>
@@ -7504,6 +7589,10 @@
             </a:outerShdw>
           </a:effectLst>
         </p:spPr>
+        <p:txBody>
+          <a:bodyPr/>
+          <a:p/>
+        </p:txBody>
       </p:sp>
       <p:sp>
         <p:nvSpPr>
@@ -7619,6 +7708,10 @@
             </a:outerShdw>
           </a:effectLst>
         </p:spPr>
+        <p:txBody>
+          <a:bodyPr/>
+          <a:p/>
+        </p:txBody>
       </p:sp>
       <p:sp>
         <p:nvSpPr>
@@ -7734,6 +7827,10 @@
             </a:outerShdw>
           </a:effectLst>
         </p:spPr>
+        <p:txBody>
+          <a:bodyPr/>
+          <a:p/>
+        </p:txBody>
       </p:sp>
       <p:sp>
         <p:nvSpPr>
@@ -7849,6 +7946,10 @@
             </a:outerShdw>
           </a:effectLst>
         </p:spPr>
+        <p:txBody>
+          <a:bodyPr/>
+          <a:p/>
+        </p:txBody>
       </p:sp>
       <p:sp>
         <p:nvSpPr>
@@ -8117,6 +8218,10 @@
             <a:prstDash val="solid"/>
           </a:ln>
         </p:spPr>
+        <p:txBody>
+          <a:bodyPr/>
+          <a:p/>
+        </p:txBody>
       </p:sp>
       <p:sp>
         <p:nvSpPr>
@@ -8137,6 +8242,10 @@
           </a:solidFill>
           <a:ln/>
         </p:spPr>
+        <p:txBody>
+          <a:bodyPr/>
+          <a:p/>
+        </p:txBody>
       </p:sp>
       <p:sp>
         <p:nvSpPr>
@@ -8287,6 +8396,10 @@
             <a:prstDash val="solid"/>
           </a:ln>
         </p:spPr>
+        <p:txBody>
+          <a:bodyPr/>
+          <a:p/>
+        </p:txBody>
       </p:sp>
       <p:sp>
         <p:nvSpPr>
@@ -8307,6 +8420,10 @@
           </a:solidFill>
           <a:ln/>
         </p:spPr>
+        <p:txBody>
+          <a:bodyPr/>
+          <a:p/>
+        </p:txBody>
       </p:sp>
       <p:sp>
         <p:nvSpPr>
@@ -8457,6 +8574,10 @@
             <a:prstDash val="solid"/>
           </a:ln>
         </p:spPr>
+        <p:txBody>
+          <a:bodyPr/>
+          <a:p/>
+        </p:txBody>
       </p:sp>
       <p:sp>
         <p:nvSpPr>
@@ -8477,6 +8598,10 @@
           </a:solidFill>
           <a:ln/>
         </p:spPr>
+        <p:txBody>
+          <a:bodyPr/>
+          <a:p/>
+        </p:txBody>
       </p:sp>
       <p:sp>
         <p:nvSpPr>
@@ -8815,6 +8940,10 @@
             </a:outerShdw>
           </a:effectLst>
         </p:spPr>
+        <p:txBody>
+          <a:bodyPr/>
+          <a:p/>
+        </p:txBody>
       </p:sp>
       <p:sp>
         <p:nvSpPr>
@@ -8835,6 +8964,10 @@
           </a:solidFill>
           <a:ln/>
         </p:spPr>
+        <p:txBody>
+          <a:bodyPr/>
+          <a:p/>
+        </p:txBody>
       </p:sp>
       <p:sp>
         <p:nvSpPr>
@@ -8986,6 +9119,10 @@
             </a:outerShdw>
           </a:effectLst>
         </p:spPr>
+        <p:txBody>
+          <a:bodyPr/>
+          <a:p/>
+        </p:txBody>
       </p:sp>
       <p:sp>
         <p:nvSpPr>
@@ -9006,6 +9143,10 @@
           </a:solidFill>
           <a:ln/>
         </p:spPr>
+        <p:txBody>
+          <a:bodyPr/>
+          <a:p/>
+        </p:txBody>
       </p:sp>
       <p:sp>
         <p:nvSpPr>
@@ -9157,6 +9298,10 @@
             </a:outerShdw>
           </a:effectLst>
         </p:spPr>
+        <p:txBody>
+          <a:bodyPr/>
+          <a:p/>
+        </p:txBody>
       </p:sp>
       <p:sp>
         <p:nvSpPr>
@@ -9177,6 +9322,10 @@
           </a:solidFill>
           <a:ln/>
         </p:spPr>
+        <p:txBody>
+          <a:bodyPr/>
+          <a:p/>
+        </p:txBody>
       </p:sp>
       <p:sp>
         <p:nvSpPr>
@@ -9328,6 +9477,10 @@
             </a:outerShdw>
           </a:effectLst>
         </p:spPr>
+        <p:txBody>
+          <a:bodyPr/>
+          <a:p/>
+        </p:txBody>
       </p:sp>
       <p:sp>
         <p:nvSpPr>
@@ -9348,6 +9501,10 @@
           </a:solidFill>
           <a:ln/>
         </p:spPr>
+        <p:txBody>
+          <a:bodyPr/>
+          <a:p/>
+        </p:txBody>
       </p:sp>
       <p:sp>
         <p:nvSpPr>
@@ -9499,6 +9656,10 @@
             </a:outerShdw>
           </a:effectLst>
         </p:spPr>
+        <p:txBody>
+          <a:bodyPr/>
+          <a:p/>
+        </p:txBody>
       </p:sp>
       <p:sp>
         <p:nvSpPr>
@@ -9519,6 +9680,10 @@
           </a:solidFill>
           <a:ln/>
         </p:spPr>
+        <p:txBody>
+          <a:bodyPr/>
+          <a:p/>
+        </p:txBody>
       </p:sp>
       <p:sp>
         <p:nvSpPr>
@@ -9670,6 +9835,10 @@
             </a:outerShdw>
           </a:effectLst>
         </p:spPr>
+        <p:txBody>
+          <a:bodyPr/>
+          <a:p/>
+        </p:txBody>
       </p:sp>
       <p:sp>
         <p:nvSpPr>
@@ -9690,6 +9859,10 @@
           </a:solidFill>
           <a:ln/>
         </p:spPr>
+        <p:txBody>
+          <a:bodyPr/>
+          <a:p/>
+        </p:txBody>
       </p:sp>
       <p:sp>
         <p:nvSpPr>
@@ -10022,6 +10195,10 @@
             </a:outerShdw>
           </a:effectLst>
         </p:spPr>
+        <p:txBody>
+          <a:bodyPr/>
+          <a:p/>
+        </p:txBody>
       </p:sp>
       <p:sp>
         <p:nvSpPr>
@@ -10137,6 +10314,10 @@
             </a:outerShdw>
           </a:effectLst>
         </p:spPr>
+        <p:txBody>
+          <a:bodyPr/>
+          <a:p/>
+        </p:txBody>
       </p:sp>
       <p:sp>
         <p:nvSpPr>
@@ -10252,6 +10433,10 @@
             </a:outerShdw>
           </a:effectLst>
         </p:spPr>
+        <p:txBody>
+          <a:bodyPr/>
+          <a:p/>
+        </p:txBody>
       </p:sp>
       <p:sp>
         <p:nvSpPr>
@@ -10367,6 +10552,10 @@
             </a:outerShdw>
           </a:effectLst>
         </p:spPr>
+        <p:txBody>
+          <a:bodyPr/>
+          <a:p/>
+        </p:txBody>
       </p:sp>
       <p:sp>
         <p:nvSpPr>
@@ -10868,6 +11057,10 @@
             </a:outerShdw>
           </a:effectLst>
         </p:spPr>
+        <p:txBody>
+          <a:bodyPr/>
+          <a:p/>
+        </p:txBody>
       </p:sp>
       <p:sp>
         <p:nvSpPr>
@@ -10973,6 +11166,10 @@
             <a:prstDash val="solid"/>
           </a:ln>
         </p:spPr>
+        <p:txBody>
+          <a:bodyPr/>
+          <a:p/>
+        </p:txBody>
       </p:sp>
       <p:sp>
         <p:nvSpPr>
@@ -11046,6 +11243,10 @@
             </a:outerShdw>
           </a:effectLst>
         </p:spPr>
+        <p:txBody>
+          <a:bodyPr/>
+          <a:p/>
+        </p:txBody>
       </p:sp>
       <p:sp>
         <p:nvSpPr>
@@ -11151,6 +11352,10 @@
             <a:prstDash val="solid"/>
           </a:ln>
         </p:spPr>
+        <p:txBody>
+          <a:bodyPr/>
+          <a:p/>
+        </p:txBody>
       </p:sp>
       <p:sp>
         <p:nvSpPr>
@@ -11224,6 +11429,10 @@
             </a:outerShdw>
           </a:effectLst>
         </p:spPr>
+        <p:txBody>
+          <a:bodyPr/>
+          <a:p/>
+        </p:txBody>
       </p:sp>
       <p:sp>
         <p:nvSpPr>
@@ -11329,6 +11538,10 @@
             <a:prstDash val="solid"/>
           </a:ln>
         </p:spPr>
+        <p:txBody>
+          <a:bodyPr/>
+          <a:p/>
+        </p:txBody>
       </p:sp>
       <p:sp>
         <p:nvSpPr>
@@ -11402,6 +11615,10 @@
             </a:outerShdw>
           </a:effectLst>
         </p:spPr>
+        <p:txBody>
+          <a:bodyPr/>
+          <a:p/>
+        </p:txBody>
       </p:sp>
       <p:sp>
         <p:nvSpPr>
@@ -11507,6 +11724,10 @@
             <a:prstDash val="solid"/>
           </a:ln>
         </p:spPr>
+        <p:txBody>
+          <a:bodyPr/>
+          <a:p/>
+        </p:txBody>
       </p:sp>
       <p:sp>
         <p:nvSpPr>
@@ -11580,6 +11801,10 @@
             </a:outerShdw>
           </a:effectLst>
         </p:spPr>
+        <p:txBody>
+          <a:bodyPr/>
+          <a:p/>
+        </p:txBody>
       </p:sp>
       <p:sp>
         <p:nvSpPr>
@@ -11685,6 +11910,10 @@
             <a:prstDash val="solid"/>
           </a:ln>
         </p:spPr>
+        <p:txBody>
+          <a:bodyPr/>
+          <a:p/>
+        </p:txBody>
       </p:sp>
       <p:sp>
         <p:nvSpPr>
@@ -11978,6 +12207,10 @@
             </a:outerShdw>
           </a:effectLst>
         </p:spPr>
+        <p:txBody>
+          <a:bodyPr/>
+          <a:p/>
+        </p:txBody>
       </p:sp>
       <p:sp>
         <p:nvSpPr>
@@ -12132,6 +12365,10 @@
             </a:outerShdw>
           </a:effectLst>
         </p:spPr>
+        <p:txBody>
+          <a:bodyPr/>
+          <a:p/>
+        </p:txBody>
       </p:sp>
       <p:sp>
         <p:nvSpPr>
@@ -12286,6 +12523,10 @@
             </a:outerShdw>
           </a:effectLst>
         </p:spPr>
+        <p:txBody>
+          <a:bodyPr/>
+          <a:p/>
+        </p:txBody>
       </p:sp>
       <p:sp>
         <p:nvSpPr>
@@ -12440,6 +12681,10 @@
             </a:outerShdw>
           </a:effectLst>
         </p:spPr>
+        <p:txBody>
+          <a:bodyPr/>
+          <a:p/>
+        </p:txBody>
       </p:sp>
       <p:sp>
         <p:nvSpPr>
@@ -12775,6 +13020,10 @@
             </a:outerShdw>
           </a:effectLst>
         </p:spPr>
+        <p:txBody>
+          <a:bodyPr/>
+          <a:p/>
+        </p:txBody>
       </p:sp>
       <p:sp>
         <p:nvSpPr>
@@ -12975,6 +13224,10 @@
             </a:outerShdw>
           </a:effectLst>
         </p:spPr>
+        <p:txBody>
+          <a:bodyPr/>
+          <a:p/>
+        </p:txBody>
       </p:sp>
       <p:sp>
         <p:nvSpPr>
@@ -13568,6 +13821,648 @@
 </p:sld>
 </file>
 
+<file path=ppt/slides/slide26.xml><?xml version="1.0" encoding="utf-8"?>
+<p:sld xmlns:a="http://schemas.openxmlformats.org/drawingml/2006/main" xmlns:p="http://schemas.openxmlformats.org/presentationml/2006/main" xmlns:r="http://schemas.openxmlformats.org/officeDocument/2006/relationships">
+  <p:cSld>
+    <p:spTree>
+      <p:nvGrpSpPr>
+        <p:cNvPr id="1" name=""/>
+        <p:cNvGrpSpPr/>
+        <p:nvPr/>
+      </p:nvGrpSpPr>
+      <p:grpSpPr/>
+      <p:sp>
+        <p:nvSpPr>
+          <p:cNvPr id="2" name="TextBox 1"/>
+          <p:cNvSpPr txBox="1"/>
+          <p:nvPr/>
+        </p:nvSpPr>
+        <p:spPr>
+          <a:xfrm>
+            <a:off x="502920" y="384048"/>
+            <a:ext cx="10972800" cy="292608"/>
+          </a:xfrm>
+          <a:prstGeom prst="rect">
+            <a:avLst/>
+          </a:prstGeom>
+          <a:noFill/>
+        </p:spPr>
+        <p:txBody>
+          <a:bodyPr wrap="square" lIns="0" rIns="0" tIns="0" bIns="0" anchor="ctr">
+            <a:spAutoFit/>
+          </a:bodyPr>
+          <a:lstStyle/>
+          <a:p>
+            <a:r>
+              <a:rPr sz="1200" b="1" i="0" spc="200">
+                <a:solidFill>
+                  <a:srgbClr val="0E8C86"/>
+                </a:solidFill>
+                <a:latin typeface="Calibri"/>
+              </a:rPr>
+              <a:t>RESULTADOS · SÍNTESE VISUAL</a:t>
+            </a:r>
+          </a:p>
+        </p:txBody>
+      </p:sp>
+      <p:sp>
+        <p:nvSpPr>
+          <p:cNvPr id="3" name="TextBox 2"/>
+          <p:cNvSpPr txBox="1"/>
+          <p:nvPr/>
+        </p:nvSpPr>
+        <p:spPr>
+          <a:xfrm>
+            <a:off x="457200" y="676656"/>
+            <a:ext cx="11247120" cy="914400"/>
+          </a:xfrm>
+          <a:prstGeom prst="rect">
+            <a:avLst/>
+          </a:prstGeom>
+          <a:noFill/>
+        </p:spPr>
+        <p:txBody>
+          <a:bodyPr wrap="square" lIns="0" rIns="0" tIns="0" bIns="0" anchor="ctr">
+            <a:spAutoFit/>
+          </a:bodyPr>
+          <a:lstStyle/>
+          <a:p>
+            <a:r>
+              <a:rPr sz="2900" b="1" i="0">
+                <a:solidFill>
+                  <a:srgbClr val="14243A"/>
+                </a:solidFill>
+                <a:latin typeface="Cambria"/>
+              </a:rPr>
+              <a:t>Painel de monitoramento e visualizações</a:t>
+            </a:r>
+          </a:p>
+        </p:txBody>
+      </p:sp>
+      <p:pic>
+        <p:nvPicPr>
+          <p:cNvPr id="4" name="Picture 3" descr="monitoramento_viz.png"/>
+          <p:cNvPicPr>
+            <a:picLocks noChangeAspect="1"/>
+          </p:cNvPicPr>
+          <p:nvPr/>
+        </p:nvPicPr>
+        <p:blipFill>
+          <a:blip r:embed="rId2"/>
+          <a:stretch>
+            <a:fillRect/>
+          </a:stretch>
+        </p:blipFill>
+        <p:spPr>
+          <a:xfrm>
+            <a:off x="502920" y="1600200"/>
+            <a:ext cx="5394960" cy="4105000"/>
+          </a:xfrm>
+          <a:prstGeom prst="rect">
+            <a:avLst/>
+          </a:prstGeom>
+        </p:spPr>
+      </p:pic>
+      <p:sp>
+        <p:nvSpPr>
+          <p:cNvPr id="5" name="Rounded Rectangle 4"/>
+          <p:cNvSpPr/>
+          <p:nvPr/>
+        </p:nvSpPr>
+        <p:spPr>
+          <a:xfrm>
+            <a:off x="6126480" y="1600200"/>
+            <a:ext cx="5532120" cy="900000"/>
+          </a:xfrm>
+          <a:prstGeom prst="roundRect">
+            <a:avLst>
+              <a:gd name="adj" fmla="val 9000"/>
+            </a:avLst>
+          </a:prstGeom>
+          <a:solidFill>
+            <a:srgbClr val="F5F8FC"/>
+          </a:solidFill>
+          <a:ln w="12700">
+            <a:solidFill>
+              <a:srgbClr val="DCE4EE"/>
+            </a:solidFill>
+          </a:ln>
+          <a:effectLst/>
+        </p:spPr>
+        <p:style>
+          <a:lnRef idx="1">
+            <a:schemeClr val="accent1"/>
+          </a:lnRef>
+          <a:fillRef idx="3">
+            <a:schemeClr val="accent1"/>
+          </a:fillRef>
+          <a:effectRef idx="2">
+            <a:schemeClr val="accent1"/>
+          </a:effectRef>
+          <a:fontRef idx="minor">
+            <a:schemeClr val="lt1"/>
+          </a:fontRef>
+        </p:style>
+        <p:txBody>
+          <a:bodyPr rtlCol="0" anchor="ctr"/>
+          <a:lstStyle/>
+          <a:p>
+            <a:pPr algn="ctr"/>
+          </a:p>
+        </p:txBody>
+      </p:sp>
+      <p:sp>
+        <p:nvSpPr>
+          <p:cNvPr id="6" name="TextBox 5"/>
+          <p:cNvSpPr txBox="1"/>
+          <p:nvPr/>
+        </p:nvSpPr>
+        <p:spPr>
+          <a:xfrm>
+            <a:off x="6355080" y="1660200"/>
+            <a:ext cx="5074920" cy="780000"/>
+          </a:xfrm>
+          <a:prstGeom prst="rect">
+            <a:avLst/>
+          </a:prstGeom>
+          <a:noFill/>
+        </p:spPr>
+        <p:txBody>
+          <a:bodyPr wrap="square" lIns="0" rIns="0" tIns="0" bIns="0" anchor="ctr">
+            <a:spAutoFit/>
+          </a:bodyPr>
+          <a:lstStyle/>
+          <a:p>
+            <a:r>
+              <a:rPr sz="1500" b="1" i="0">
+                <a:solidFill>
+                  <a:srgbClr val="245C8B"/>
+                </a:solidFill>
+                <a:latin typeface="Cambria"/>
+              </a:rPr>
+              <a:t>A · Medidores (gauge)</a:t>
+            </a:r>
+          </a:p>
+          <a:p>
+            <a:r>
+              <a:rPr sz="1150" b="0" i="0">
+                <a:solidFill>
+                  <a:srgbClr val="5B6B82"/>
+                </a:solidFill>
+                <a:latin typeface="Calibri"/>
+              </a:rPr>
+              <a:t>indicadores-chave sobre zonas de referência: dz fadiga física, AUC, perfil iceberg e HTMT</a:t>
+            </a:r>
+          </a:p>
+        </p:txBody>
+      </p:sp>
+      <p:sp>
+        <p:nvSpPr>
+          <p:cNvPr id="7" name="Rounded Rectangle 6"/>
+          <p:cNvSpPr/>
+          <p:nvPr/>
+        </p:nvSpPr>
+        <p:spPr>
+          <a:xfrm>
+            <a:off x="6126480" y="2630200"/>
+            <a:ext cx="5532120" cy="900000"/>
+          </a:xfrm>
+          <a:prstGeom prst="roundRect">
+            <a:avLst>
+              <a:gd name="adj" fmla="val 9000"/>
+            </a:avLst>
+          </a:prstGeom>
+          <a:solidFill>
+            <a:srgbClr val="F5F8FC"/>
+          </a:solidFill>
+          <a:ln w="12700">
+            <a:solidFill>
+              <a:srgbClr val="DCE4EE"/>
+            </a:solidFill>
+          </a:ln>
+          <a:effectLst/>
+        </p:spPr>
+        <p:style>
+          <a:lnRef idx="1">
+            <a:schemeClr val="accent1"/>
+          </a:lnRef>
+          <a:fillRef idx="3">
+            <a:schemeClr val="accent1"/>
+          </a:fillRef>
+          <a:effectRef idx="2">
+            <a:schemeClr val="accent1"/>
+          </a:effectRef>
+          <a:fontRef idx="minor">
+            <a:schemeClr val="lt1"/>
+          </a:fontRef>
+        </p:style>
+        <p:txBody>
+          <a:bodyPr rtlCol="0" anchor="ctr"/>
+          <a:lstStyle/>
+          <a:p>
+            <a:pPr algn="ctr"/>
+          </a:p>
+        </p:txBody>
+      </p:sp>
+      <p:sp>
+        <p:nvSpPr>
+          <p:cNvPr id="8" name="TextBox 7"/>
+          <p:cNvSpPr txBox="1"/>
+          <p:nvPr/>
+        </p:nvSpPr>
+        <p:spPr>
+          <a:xfrm>
+            <a:off x="6355080" y="2690200"/>
+            <a:ext cx="5074920" cy="780000"/>
+          </a:xfrm>
+          <a:prstGeom prst="rect">
+            <a:avLst/>
+          </a:prstGeom>
+          <a:noFill/>
+        </p:spPr>
+        <p:txBody>
+          <a:bodyPr wrap="square" lIns="0" rIns="0" tIns="0" bIns="0" anchor="ctr">
+            <a:spAutoFit/>
+          </a:bodyPr>
+          <a:lstStyle/>
+          <a:p>
+            <a:r>
+              <a:rPr sz="1500" b="1" i="0">
+                <a:solidFill>
+                  <a:srgbClr val="C0392B"/>
+                </a:solidFill>
+                <a:latin typeface="Cambria"/>
+              </a:rPr>
+              <a:t>B · Radar do humor</a:t>
+            </a:r>
+          </a:p>
+          <a:p>
+            <a:r>
+              <a:rPr sz="1150" b="0" i="0">
+                <a:solidFill>
+                  <a:srgbClr val="5B6B82"/>
+                </a:solidFill>
+                <a:latin typeface="Calibri"/>
+              </a:rPr>
+              <a:t>perfil das 6 subescalas pré vs. pós — a “montanha” de vigor achata (erosão do iceberg)</a:t>
+            </a:r>
+          </a:p>
+        </p:txBody>
+      </p:sp>
+      <p:sp>
+        <p:nvSpPr>
+          <p:cNvPr id="9" name="Rounded Rectangle 8"/>
+          <p:cNvSpPr/>
+          <p:nvPr/>
+        </p:nvSpPr>
+        <p:spPr>
+          <a:xfrm>
+            <a:off x="6126480" y="3660200"/>
+            <a:ext cx="5532120" cy="900000"/>
+          </a:xfrm>
+          <a:prstGeom prst="roundRect">
+            <a:avLst>
+              <a:gd name="adj" fmla="val 9000"/>
+            </a:avLst>
+          </a:prstGeom>
+          <a:solidFill>
+            <a:srgbClr val="F5F8FC"/>
+          </a:solidFill>
+          <a:ln w="12700">
+            <a:solidFill>
+              <a:srgbClr val="DCE4EE"/>
+            </a:solidFill>
+          </a:ln>
+          <a:effectLst/>
+        </p:spPr>
+        <p:style>
+          <a:lnRef idx="1">
+            <a:schemeClr val="accent1"/>
+          </a:lnRef>
+          <a:fillRef idx="3">
+            <a:schemeClr val="accent1"/>
+          </a:fillRef>
+          <a:effectRef idx="2">
+            <a:schemeClr val="accent1"/>
+          </a:effectRef>
+          <a:fontRef idx="minor">
+            <a:schemeClr val="lt1"/>
+          </a:fontRef>
+        </p:style>
+        <p:txBody>
+          <a:bodyPr rtlCol="0" anchor="ctr"/>
+          <a:lstStyle/>
+          <a:p>
+            <a:pPr algn="ctr"/>
+          </a:p>
+        </p:txBody>
+      </p:sp>
+      <p:sp>
+        <p:nvSpPr>
+          <p:cNvPr id="10" name="TextBox 9"/>
+          <p:cNvSpPr txBox="1"/>
+          <p:nvPr/>
+        </p:nvSpPr>
+        <p:spPr>
+          <a:xfrm>
+            <a:off x="6355080" y="3720200"/>
+            <a:ext cx="5074920" cy="780000"/>
+          </a:xfrm>
+          <a:prstGeom prst="rect">
+            <a:avLst/>
+          </a:prstGeom>
+          <a:noFill/>
+        </p:spPr>
+        <p:txBody>
+          <a:bodyPr wrap="square" lIns="0" rIns="0" tIns="0" bIns="0" anchor="ctr">
+            <a:spAutoFit/>
+          </a:bodyPr>
+          <a:lstStyle/>
+          <a:p>
+            <a:r>
+              <a:rPr sz="1500" b="1" i="0">
+                <a:solidFill>
+                  <a:srgbClr val="C7871B"/>
+                </a:solidFill>
+                <a:latin typeface="Cambria"/>
+              </a:rPr>
+              <a:t>C · Monitoramento diário</a:t>
+            </a:r>
+          </a:p>
+          <a:p>
+            <a:r>
+              <a:rPr sz="1150" b="0" i="0">
+                <a:solidFill>
+                  <a:srgbClr val="5B6B82"/>
+                </a:solidFill>
+                <a:latin typeface="Calibri"/>
+              </a:rPr>
+              <a:t>carga de humor D1→D7 com faixas de alerta e dias de HIIT — pico no D7</a:t>
+            </a:r>
+          </a:p>
+        </p:txBody>
+      </p:sp>
+      <p:sp>
+        <p:nvSpPr>
+          <p:cNvPr id="11" name="Rounded Rectangle 10"/>
+          <p:cNvSpPr/>
+          <p:nvPr/>
+        </p:nvSpPr>
+        <p:spPr>
+          <a:xfrm>
+            <a:off x="6126480" y="4690200"/>
+            <a:ext cx="5532120" cy="900000"/>
+          </a:xfrm>
+          <a:prstGeom prst="roundRect">
+            <a:avLst>
+              <a:gd name="adj" fmla="val 9000"/>
+            </a:avLst>
+          </a:prstGeom>
+          <a:solidFill>
+            <a:srgbClr val="F5F8FC"/>
+          </a:solidFill>
+          <a:ln w="12700">
+            <a:solidFill>
+              <a:srgbClr val="DCE4EE"/>
+            </a:solidFill>
+          </a:ln>
+          <a:effectLst/>
+        </p:spPr>
+        <p:style>
+          <a:lnRef idx="1">
+            <a:schemeClr val="accent1"/>
+          </a:lnRef>
+          <a:fillRef idx="3">
+            <a:schemeClr val="accent1"/>
+          </a:fillRef>
+          <a:effectRef idx="2">
+            <a:schemeClr val="accent1"/>
+          </a:effectRef>
+          <a:fontRef idx="minor">
+            <a:schemeClr val="lt1"/>
+          </a:fontRef>
+        </p:style>
+        <p:txBody>
+          <a:bodyPr rtlCol="0" anchor="ctr"/>
+          <a:lstStyle/>
+          <a:p>
+            <a:pPr algn="ctr"/>
+          </a:p>
+        </p:txBody>
+      </p:sp>
+      <p:sp>
+        <p:nvSpPr>
+          <p:cNvPr id="12" name="TextBox 11"/>
+          <p:cNvSpPr txBox="1"/>
+          <p:nvPr/>
+        </p:nvSpPr>
+        <p:spPr>
+          <a:xfrm>
+            <a:off x="6355080" y="4750200"/>
+            <a:ext cx="5074920" cy="780000"/>
+          </a:xfrm>
+          <a:prstGeom prst="rect">
+            <a:avLst/>
+          </a:prstGeom>
+          <a:noFill/>
+        </p:spPr>
+        <p:txBody>
+          <a:bodyPr wrap="square" lIns="0" rIns="0" tIns="0" bIns="0" anchor="ctr">
+            <a:spAutoFit/>
+          </a:bodyPr>
+          <a:lstStyle/>
+          <a:p>
+            <a:r>
+              <a:rPr sz="1500" b="1" i="0">
+                <a:solidFill>
+                  <a:srgbClr val="7A4FB0"/>
+                </a:solidFill>
+                <a:latin typeface="Cambria"/>
+              </a:rPr>
+              <a:t>D · Mapa 4D das variáveis</a:t>
+            </a:r>
+          </a:p>
+          <a:p>
+            <a:r>
+              <a:rPr sz="1150" b="0" i="0">
+                <a:solidFill>
+                  <a:srgbClr val="5B6B82"/>
+                </a:solidFill>
+                <a:latin typeface="Calibri"/>
+              </a:rPr>
+              <a:t>resposta aguda × acúmulo × individualidade × consenso direcional por variável</a:t>
+            </a:r>
+          </a:p>
+        </p:txBody>
+      </p:sp>
+      <p:sp>
+        <p:nvSpPr>
+          <p:cNvPr id="13" name="Rounded Rectangle 12"/>
+          <p:cNvSpPr/>
+          <p:nvPr/>
+        </p:nvSpPr>
+        <p:spPr>
+          <a:xfrm>
+            <a:off x="548640" y="5806440"/>
+            <a:ext cx="11109960" cy="658368"/>
+          </a:xfrm>
+          <a:prstGeom prst="roundRect">
+            <a:avLst>
+              <a:gd name="adj" fmla="val 12500"/>
+            </a:avLst>
+          </a:prstGeom>
+          <a:solidFill>
+            <a:srgbClr val="F5F8FC"/>
+          </a:solidFill>
+          <a:ln w="12700">
+            <a:solidFill>
+              <a:srgbClr val="DCE4EE"/>
+            </a:solidFill>
+          </a:ln>
+          <a:effectLst/>
+        </p:spPr>
+        <p:style>
+          <a:lnRef idx="1">
+            <a:schemeClr val="accent1"/>
+          </a:lnRef>
+          <a:fillRef idx="3">
+            <a:schemeClr val="accent1"/>
+          </a:fillRef>
+          <a:effectRef idx="2">
+            <a:schemeClr val="accent1"/>
+          </a:effectRef>
+          <a:fontRef idx="minor">
+            <a:schemeClr val="lt1"/>
+          </a:fontRef>
+        </p:style>
+        <p:txBody>
+          <a:bodyPr rtlCol="0" anchor="ctr"/>
+          <a:lstStyle/>
+          <a:p>
+            <a:pPr algn="ctr"/>
+          </a:p>
+        </p:txBody>
+      </p:sp>
+      <p:sp>
+        <p:nvSpPr>
+          <p:cNvPr id="14" name="TextBox 13"/>
+          <p:cNvSpPr txBox="1"/>
+          <p:nvPr/>
+        </p:nvSpPr>
+        <p:spPr>
+          <a:xfrm>
+            <a:off x="777240" y="5806440"/>
+            <a:ext cx="10698480" cy="658368"/>
+          </a:xfrm>
+          <a:prstGeom prst="rect">
+            <a:avLst/>
+          </a:prstGeom>
+          <a:noFill/>
+        </p:spPr>
+        <p:txBody>
+          <a:bodyPr wrap="square" lIns="0" rIns="0" tIns="0" bIns="0" anchor="ctr">
+            <a:spAutoFit/>
+          </a:bodyPr>
+          <a:lstStyle/>
+          <a:p>
+            <a:r>
+              <a:rPr sz="1350" b="1" i="0">
+                <a:solidFill>
+                  <a:srgbClr val="C7871B"/>
+                </a:solidFill>
+                <a:latin typeface="Calibri"/>
+              </a:rPr>
+              <a:t>▸  </a:t>
+            </a:r>
+            <a:r>
+              <a:rPr sz="1350" b="1" i="0">
+                <a:solidFill>
+                  <a:srgbClr val="14243A"/>
+                </a:solidFill>
+                <a:latin typeface="Calibri"/>
+              </a:rPr>
+              <a:t>Um só painel resume as três âncoras do estudo: resposta no eixo energia–fadiga, forte individualidade entre atletas e monitoramento por tendência (a fadiga física é a sentinela).</a:t>
+            </a:r>
+          </a:p>
+        </p:txBody>
+      </p:sp>
+      <p:sp>
+        <p:nvSpPr>
+          <p:cNvPr id="15" name="TextBox 14"/>
+          <p:cNvSpPr txBox="1"/>
+          <p:nvPr/>
+        </p:nvSpPr>
+        <p:spPr>
+          <a:xfrm>
+            <a:off x="457200" y="6473952"/>
+            <a:ext cx="8229600" cy="274320"/>
+          </a:xfrm>
+          <a:prstGeom prst="rect">
+            <a:avLst/>
+          </a:prstGeom>
+          <a:noFill/>
+        </p:spPr>
+        <p:txBody>
+          <a:bodyPr wrap="square" lIns="0" rIns="0" tIns="0" bIns="0" anchor="ctr">
+            <a:spAutoFit/>
+          </a:bodyPr>
+          <a:lstStyle/>
+          <a:p>
+            <a:r>
+              <a:rPr sz="900" b="0" i="0">
+                <a:solidFill>
+                  <a:srgbClr val="93A1B5"/>
+                </a:solidFill>
+                <a:latin typeface="Calibri"/>
+              </a:rPr>
+              <a:t>Síntese visual · monitoramento</a:t>
+            </a:r>
+          </a:p>
+        </p:txBody>
+      </p:sp>
+      <p:sp>
+        <p:nvSpPr>
+          <p:cNvPr id="16" name="TextBox 15"/>
+          <p:cNvSpPr txBox="1"/>
+          <p:nvPr/>
+        </p:nvSpPr>
+        <p:spPr>
+          <a:xfrm>
+            <a:off x="11247120" y="6473952"/>
+            <a:ext cx="548640" cy="274320"/>
+          </a:xfrm>
+          <a:prstGeom prst="rect">
+            <a:avLst/>
+          </a:prstGeom>
+          <a:noFill/>
+        </p:spPr>
+        <p:txBody>
+          <a:bodyPr wrap="square" lIns="0" rIns="0" tIns="0" bIns="0" anchor="ctr">
+            <a:spAutoFit/>
+          </a:bodyPr>
+          <a:lstStyle/>
+          <a:p>
+            <a:pPr algn="r"/>
+            <a:r>
+              <a:rPr sz="900" b="0" i="0">
+                <a:solidFill>
+                  <a:srgbClr val="93A1B5"/>
+                </a:solidFill>
+                <a:latin typeface="Calibri"/>
+              </a:rPr>
+              <a:t>26</a:t>
+            </a:r>
+          </a:p>
+        </p:txBody>
+      </p:sp>
+    </p:spTree>
+  </p:cSld>
+  <p:clrMapOvr>
+    <a:masterClrMapping/>
+  </p:clrMapOvr>
+</p:sld>
+</file>
+
 <file path=ppt/slides/slide3.xml><?xml version="1.0" encoding="utf-8"?>
 <p:sld xmlns:a="http://schemas.openxmlformats.org/drawingml/2006/main" xmlns:r="http://schemas.openxmlformats.org/officeDocument/2006/relationships" xmlns:p="http://schemas.openxmlformats.org/presentationml/2006/main">
   <p:cSld name="Slide 3">
@@ -13755,6 +14650,10 @@
             </a:outerShdw>
           </a:effectLst>
         </p:spPr>
+        <p:txBody>
+          <a:bodyPr/>
+          <a:p/>
+        </p:txBody>
       </p:sp>
       <p:sp>
         <p:nvSpPr>
@@ -13906,6 +14805,10 @@
             </a:outerShdw>
           </a:effectLst>
         </p:spPr>
+        <p:txBody>
+          <a:bodyPr/>
+          <a:p/>
+        </p:txBody>
       </p:sp>
       <p:sp>
         <p:nvSpPr>
@@ -14057,6 +14960,10 @@
             </a:outerShdw>
           </a:effectLst>
         </p:spPr>
+        <p:txBody>
+          <a:bodyPr/>
+          <a:p/>
+        </p:txBody>
       </p:sp>
       <p:sp>
         <p:nvSpPr>
@@ -14208,6 +15115,10 @@
             </a:outerShdw>
           </a:effectLst>
         </p:spPr>
+        <p:txBody>
+          <a:bodyPr/>
+          <a:p/>
+        </p:txBody>
       </p:sp>
       <p:sp>
         <p:nvSpPr>
@@ -14546,6 +15457,10 @@
             </a:outerShdw>
           </a:effectLst>
         </p:spPr>
+        <p:txBody>
+          <a:bodyPr/>
+          <a:p/>
+        </p:txBody>
       </p:sp>
       <p:sp>
         <p:nvSpPr>
@@ -14700,6 +15615,10 @@
             </a:outerShdw>
           </a:effectLst>
         </p:spPr>
+        <p:txBody>
+          <a:bodyPr/>
+          <a:p/>
+        </p:txBody>
       </p:sp>
       <p:sp>
         <p:nvSpPr>
@@ -15359,6 +16278,10 @@
             </a:outerShdw>
           </a:effectLst>
         </p:spPr>
+        <p:txBody>
+          <a:bodyPr/>
+          <a:p/>
+        </p:txBody>
       </p:sp>
       <p:sp>
         <p:nvSpPr>
@@ -15379,6 +16302,10 @@
           </a:solidFill>
           <a:ln/>
         </p:spPr>
+        <p:txBody>
+          <a:bodyPr/>
+          <a:p/>
+        </p:txBody>
       </p:sp>
       <p:sp>
         <p:nvSpPr>
@@ -15600,6 +16527,10 @@
             </a:outerShdw>
           </a:effectLst>
         </p:spPr>
+        <p:txBody>
+          <a:bodyPr/>
+          <a:p/>
+        </p:txBody>
       </p:sp>
       <p:sp>
         <p:nvSpPr>
@@ -15620,6 +16551,10 @@
           </a:solidFill>
           <a:ln/>
         </p:spPr>
+        <p:txBody>
+          <a:bodyPr/>
+          <a:p/>
+        </p:txBody>
       </p:sp>
       <p:sp>
         <p:nvSpPr>
@@ -15862,6 +16797,10 @@
             </a:outerShdw>
           </a:effectLst>
         </p:spPr>
+        <p:txBody>
+          <a:bodyPr/>
+          <a:p/>
+        </p:txBody>
       </p:sp>
       <p:sp>
         <p:nvSpPr>
@@ -15882,6 +16821,10 @@
           </a:solidFill>
           <a:ln/>
         </p:spPr>
+        <p:txBody>
+          <a:bodyPr/>
+          <a:p/>
+        </p:txBody>
       </p:sp>
       <p:sp>
         <p:nvSpPr>
@@ -16308,6 +17251,10 @@
             </a:outerShdw>
           </a:effectLst>
         </p:spPr>
+        <p:txBody>
+          <a:bodyPr/>
+          <a:p/>
+        </p:txBody>
       </p:sp>
       <p:sp>
         <p:nvSpPr>
@@ -16420,6 +17367,10 @@
             </a:outerShdw>
           </a:effectLst>
         </p:spPr>
+        <p:txBody>
+          <a:bodyPr/>
+          <a:p/>
+        </p:txBody>
       </p:sp>
       <p:sp>
         <p:nvSpPr>
@@ -16532,6 +17483,10 @@
             </a:outerShdw>
           </a:effectLst>
         </p:spPr>
+        <p:txBody>
+          <a:bodyPr/>
+          <a:p/>
+        </p:txBody>
       </p:sp>
       <p:sp>
         <p:nvSpPr>
@@ -16644,6 +17599,10 @@
             </a:outerShdw>
           </a:effectLst>
         </p:spPr>
+        <p:txBody>
+          <a:bodyPr/>
+          <a:p/>
+        </p:txBody>
       </p:sp>
       <p:sp>
         <p:nvSpPr>
@@ -16961,6 +17920,10 @@
             </a:outerShdw>
           </a:effectLst>
         </p:spPr>
+        <p:txBody>
+          <a:bodyPr/>
+          <a:p/>
+        </p:txBody>
       </p:sp>
       <p:sp>
         <p:nvSpPr>
@@ -17652,6 +18615,10 @@
             </a:outerShdw>
           </a:effectLst>
         </p:spPr>
+        <p:txBody>
+          <a:bodyPr/>
+          <a:p/>
+        </p:txBody>
       </p:sp>
       <p:sp>
         <p:nvSpPr>

</xml_diff>

<commit_message>
Apresentação PPTX: slides de invariância estrita/parcial e carga×humor
add_novos_slides.py (idempotente) anexa dois slides no estilo do deck:
- Invariância estrita (resíduos) e parcial — fecha a hierarquia; figura +
  4 cards (métrica sustentada, escalar aproximada, estrita no limite, parcial
  restabelece) + destaque.
- Carga interna × humor e preditores de fadiga — figura + 4 cards
  (desacoplamento, fadiga física sensível, fadiga mental/depressão sensível+
  confiável, tensão cega) + destaque.
Deck 26→28 slides; validação PPTX OK.

Co-Authored-By: Claude Opus 4.8 <noreply@anthropic.com>
Claude-Session: https://claude.ai/code/session_0157sZ1CmW4MRSmx6a9GoYrN
</commit_message>
<xml_diff>
--- a/auditoria_brums_hiit/tese/Apresentacao_BRUMS_HIIT.pptx
+++ b/auditoria_brums_hiit/tese/Apresentacao_BRUMS_HIIT.pptx
@@ -31,6 +31,8 @@
     <p:sldId id="279" r:id="rId25"/>
     <p:sldId id="280" r:id="rId26"/>
     <p:sldId id="281" r:id="rId32"/>
+    <p:sldId id="282" r:id="rId33"/>
+    <p:sldId id="283" r:id="rId34"/>
   </p:sldIdLst>
   <p:notesMasterIdLst>
     <p:notesMasterId r:id="rId27"/>
@@ -14463,6 +14465,1290 @@
 </p:sld>
 </file>
 
+<file path=ppt/slides/slide27.xml><?xml version="1.0" encoding="utf-8"?>
+<p:sld xmlns:a="http://schemas.openxmlformats.org/drawingml/2006/main" xmlns:p="http://schemas.openxmlformats.org/presentationml/2006/main" xmlns:r="http://schemas.openxmlformats.org/officeDocument/2006/relationships">
+  <p:cSld>
+    <p:spTree>
+      <p:nvGrpSpPr>
+        <p:cNvPr id="1" name=""/>
+        <p:cNvGrpSpPr/>
+        <p:nvPr/>
+      </p:nvGrpSpPr>
+      <p:grpSpPr/>
+      <p:sp>
+        <p:nvSpPr>
+          <p:cNvPr id="2" name="TextBox 1"/>
+          <p:cNvSpPr txBox="1"/>
+          <p:nvPr/>
+        </p:nvSpPr>
+        <p:spPr>
+          <a:xfrm>
+            <a:off x="502920" y="384048"/>
+            <a:ext cx="10972800" cy="292608"/>
+          </a:xfrm>
+          <a:prstGeom prst="rect">
+            <a:avLst/>
+          </a:prstGeom>
+          <a:noFill/>
+        </p:spPr>
+        <p:txBody>
+          <a:bodyPr wrap="square" lIns="0" rIns="0" tIns="0" bIns="0" anchor="ctr">
+            <a:spAutoFit/>
+          </a:bodyPr>
+          <a:lstStyle/>
+          <a:p>
+            <a:r>
+              <a:rPr sz="1200" b="1" i="0" spc="200">
+                <a:solidFill>
+                  <a:srgbClr val="0E8C86"/>
+                </a:solidFill>
+                <a:latin typeface="Calibri"/>
+              </a:rPr>
+              <a:t>RESULTADOS · INVARIÂNCIA DE MEDIDA</a:t>
+            </a:r>
+          </a:p>
+        </p:txBody>
+      </p:sp>
+      <p:sp>
+        <p:nvSpPr>
+          <p:cNvPr id="3" name="TextBox 2"/>
+          <p:cNvSpPr txBox="1"/>
+          <p:nvPr/>
+        </p:nvSpPr>
+        <p:spPr>
+          <a:xfrm>
+            <a:off x="457200" y="676656"/>
+            <a:ext cx="11247120" cy="860000"/>
+          </a:xfrm>
+          <a:prstGeom prst="rect">
+            <a:avLst/>
+          </a:prstGeom>
+          <a:noFill/>
+        </p:spPr>
+        <p:txBody>
+          <a:bodyPr wrap="square" lIns="0" rIns="0" tIns="0" bIns="0" anchor="ctr">
+            <a:spAutoFit/>
+          </a:bodyPr>
+          <a:lstStyle/>
+          <a:p>
+            <a:r>
+              <a:rPr sz="2600" b="1" i="0">
+                <a:solidFill>
+                  <a:srgbClr val="14243A"/>
+                </a:solidFill>
+                <a:latin typeface="Cambria"/>
+              </a:rPr>
+              <a:t>Invariância estrita (resíduos) e parcial</a:t>
+            </a:r>
+          </a:p>
+        </p:txBody>
+      </p:sp>
+      <p:pic>
+        <p:nvPicPr>
+          <p:cNvPr id="4" name="Picture 3" descr="invariancia_estrita_parcial_fig.png"/>
+          <p:cNvPicPr>
+            <a:picLocks noChangeAspect="1"/>
+          </p:cNvPicPr>
+          <p:nvPr/>
+        </p:nvPicPr>
+        <p:blipFill>
+          <a:blip r:embed="rId2"/>
+          <a:stretch>
+            <a:fillRect/>
+          </a:stretch>
+        </p:blipFill>
+        <p:spPr>
+          <a:xfrm>
+            <a:off x="502920" y="2109041"/>
+            <a:ext cx="6850000" cy="2661917"/>
+          </a:xfrm>
+          <a:prstGeom prst="rect">
+            <a:avLst/>
+          </a:prstGeom>
+        </p:spPr>
+      </p:pic>
+      <p:sp>
+        <p:nvSpPr>
+          <p:cNvPr id="5" name="Rounded Rectangle 4"/>
+          <p:cNvSpPr/>
+          <p:nvPr/>
+        </p:nvSpPr>
+        <p:spPr>
+          <a:xfrm>
+            <a:off x="7560000" y="1560000"/>
+            <a:ext cx="4129080" cy="827500"/>
+          </a:xfrm>
+          <a:prstGeom prst="roundRect">
+            <a:avLst>
+              <a:gd name="adj" fmla="val 9000"/>
+            </a:avLst>
+          </a:prstGeom>
+          <a:solidFill>
+            <a:srgbClr val="F5F8FC"/>
+          </a:solidFill>
+          <a:ln w="12700">
+            <a:solidFill>
+              <a:srgbClr val="DCE4EE"/>
+            </a:solidFill>
+          </a:ln>
+          <a:effectLst/>
+        </p:spPr>
+        <p:style>
+          <a:lnRef idx="1">
+            <a:schemeClr val="accent1"/>
+          </a:lnRef>
+          <a:fillRef idx="3">
+            <a:schemeClr val="accent1"/>
+          </a:fillRef>
+          <a:effectRef idx="2">
+            <a:schemeClr val="accent1"/>
+          </a:effectRef>
+          <a:fontRef idx="minor">
+            <a:schemeClr val="lt1"/>
+          </a:fontRef>
+        </p:style>
+        <p:txBody>
+          <a:bodyPr rtlCol="0" anchor="ctr"/>
+          <a:lstStyle/>
+          <a:p>
+            <a:pPr algn="ctr"/>
+          </a:p>
+        </p:txBody>
+      </p:sp>
+      <p:sp>
+        <p:nvSpPr>
+          <p:cNvPr id="6" name="TextBox 5"/>
+          <p:cNvSpPr txBox="1"/>
+          <p:nvPr/>
+        </p:nvSpPr>
+        <p:spPr>
+          <a:xfrm>
+            <a:off x="7720000" y="1615000"/>
+            <a:ext cx="3809080" cy="717500"/>
+          </a:xfrm>
+          <a:prstGeom prst="rect">
+            <a:avLst/>
+          </a:prstGeom>
+          <a:noFill/>
+        </p:spPr>
+        <p:txBody>
+          <a:bodyPr wrap="square" lIns="0" rIns="0" tIns="0" bIns="0" anchor="t">
+            <a:spAutoFit/>
+          </a:bodyPr>
+          <a:lstStyle/>
+          <a:p>
+            <a:r>
+              <a:rPr sz="1300" b="1" i="0">
+                <a:solidFill>
+                  <a:srgbClr val="245C8B"/>
+                </a:solidFill>
+                <a:latin typeface="Cambria"/>
+              </a:rPr>
+              <a:t>Métrica sustentada</a:t>
+            </a:r>
+          </a:p>
+          <a:p>
+            <a:r>
+              <a:rPr sz="1050" b="0" i="0">
+                <a:solidFill>
+                  <a:srgbClr val="5B6B82"/>
+                </a:solidFill>
+                <a:latin typeface="Calibri"/>
+              </a:rPr>
+              <a:t>ΔCFI −0,004 (modelo conjunto); Tucker φ 0,992 — as cargas são congruentes pré→pós.</a:t>
+            </a:r>
+          </a:p>
+        </p:txBody>
+      </p:sp>
+      <p:sp>
+        <p:nvSpPr>
+          <p:cNvPr id="7" name="Rounded Rectangle 6"/>
+          <p:cNvSpPr/>
+          <p:nvPr/>
+        </p:nvSpPr>
+        <p:spPr>
+          <a:xfrm>
+            <a:off x="7560000" y="2537500"/>
+            <a:ext cx="4129080" cy="827500"/>
+          </a:xfrm>
+          <a:prstGeom prst="roundRect">
+            <a:avLst>
+              <a:gd name="adj" fmla="val 9000"/>
+            </a:avLst>
+          </a:prstGeom>
+          <a:solidFill>
+            <a:srgbClr val="F5F8FC"/>
+          </a:solidFill>
+          <a:ln w="12700">
+            <a:solidFill>
+              <a:srgbClr val="DCE4EE"/>
+            </a:solidFill>
+          </a:ln>
+          <a:effectLst/>
+        </p:spPr>
+        <p:style>
+          <a:lnRef idx="1">
+            <a:schemeClr val="accent1"/>
+          </a:lnRef>
+          <a:fillRef idx="3">
+            <a:schemeClr val="accent1"/>
+          </a:fillRef>
+          <a:effectRef idx="2">
+            <a:schemeClr val="accent1"/>
+          </a:effectRef>
+          <a:fontRef idx="minor">
+            <a:schemeClr val="lt1"/>
+          </a:fontRef>
+        </p:style>
+        <p:txBody>
+          <a:bodyPr rtlCol="0" anchor="ctr"/>
+          <a:lstStyle/>
+          <a:p>
+            <a:pPr algn="ctr"/>
+          </a:p>
+        </p:txBody>
+      </p:sp>
+      <p:sp>
+        <p:nvSpPr>
+          <p:cNvPr id="8" name="TextBox 7"/>
+          <p:cNvSpPr txBox="1"/>
+          <p:nvPr/>
+        </p:nvSpPr>
+        <p:spPr>
+          <a:xfrm>
+            <a:off x="7720000" y="2592500"/>
+            <a:ext cx="3809080" cy="717500"/>
+          </a:xfrm>
+          <a:prstGeom prst="rect">
+            <a:avLst/>
+          </a:prstGeom>
+          <a:noFill/>
+        </p:spPr>
+        <p:txBody>
+          <a:bodyPr wrap="square" lIns="0" rIns="0" tIns="0" bIns="0" anchor="t">
+            <a:spAutoFit/>
+          </a:bodyPr>
+          <a:lstStyle/>
+          <a:p>
+            <a:r>
+              <a:rPr sz="1300" b="1" i="0">
+                <a:solidFill>
+                  <a:srgbClr val="2E7D5B"/>
+                </a:solidFill>
+                <a:latin typeface="Cambria"/>
+              </a:rPr>
+              <a:t>Escalar aproximada</a:t>
+            </a:r>
+          </a:p>
+          <a:p>
+            <a:r>
+              <a:rPr sz="1050" b="0" i="0">
+                <a:solidFill>
+                  <a:srgbClr val="5B6B82"/>
+                </a:solidFill>
+                <a:latin typeface="Calibri"/>
+              </a:rPr>
+              <a:t>viés residual de intercepto RMS 0,135; deslocamento latente na fadiga (+0,56) e vigor (−0,26).</a:t>
+            </a:r>
+          </a:p>
+        </p:txBody>
+      </p:sp>
+      <p:sp>
+        <p:nvSpPr>
+          <p:cNvPr id="9" name="Rounded Rectangle 8"/>
+          <p:cNvSpPr/>
+          <p:nvPr/>
+        </p:nvSpPr>
+        <p:spPr>
+          <a:xfrm>
+            <a:off x="7560000" y="3515000"/>
+            <a:ext cx="4129080" cy="827500"/>
+          </a:xfrm>
+          <a:prstGeom prst="roundRect">
+            <a:avLst>
+              <a:gd name="adj" fmla="val 9000"/>
+            </a:avLst>
+          </a:prstGeom>
+          <a:solidFill>
+            <a:srgbClr val="F5F8FC"/>
+          </a:solidFill>
+          <a:ln w="12700">
+            <a:solidFill>
+              <a:srgbClr val="DCE4EE"/>
+            </a:solidFill>
+          </a:ln>
+          <a:effectLst/>
+        </p:spPr>
+        <p:style>
+          <a:lnRef idx="1">
+            <a:schemeClr val="accent1"/>
+          </a:lnRef>
+          <a:fillRef idx="3">
+            <a:schemeClr val="accent1"/>
+          </a:fillRef>
+          <a:effectRef idx="2">
+            <a:schemeClr val="accent1"/>
+          </a:effectRef>
+          <a:fontRef idx="minor">
+            <a:schemeClr val="lt1"/>
+          </a:fontRef>
+        </p:style>
+        <p:txBody>
+          <a:bodyPr rtlCol="0" anchor="ctr"/>
+          <a:lstStyle/>
+          <a:p>
+            <a:pPr algn="ctr"/>
+          </a:p>
+        </p:txBody>
+      </p:sp>
+      <p:sp>
+        <p:nvSpPr>
+          <p:cNvPr id="10" name="TextBox 9"/>
+          <p:cNvSpPr txBox="1"/>
+          <p:nvPr/>
+        </p:nvSpPr>
+        <p:spPr>
+          <a:xfrm>
+            <a:off x="7720000" y="3570000"/>
+            <a:ext cx="3809080" cy="717500"/>
+          </a:xfrm>
+          <a:prstGeom prst="rect">
+            <a:avLst/>
+          </a:prstGeom>
+          <a:noFill/>
+        </p:spPr>
+        <p:txBody>
+          <a:bodyPr wrap="square" lIns="0" rIns="0" tIns="0" bIns="0" anchor="t">
+            <a:spAutoFit/>
+          </a:bodyPr>
+          <a:lstStyle/>
+          <a:p>
+            <a:r>
+              <a:rPr sz="1300" b="1" i="0">
+                <a:solidFill>
+                  <a:srgbClr val="C7871B"/>
+                </a:solidFill>
+                <a:latin typeface="Cambria"/>
+              </a:rPr>
+              <a:t>Estrita no limite</a:t>
+            </a:r>
+          </a:p>
+          <a:p>
+            <a:r>
+              <a:rPr sz="1050" b="0" i="0">
+                <a:solidFill>
+                  <a:srgbClr val="5B6B82"/>
+                </a:solidFill>
+                <a:latin typeface="Calibri"/>
+              </a:rPr>
+              <a:t>fixando também as variâncias de erro θ: CFI 0,913→0,898 (ΔCFI −0,015).</a:t>
+            </a:r>
+          </a:p>
+        </p:txBody>
+      </p:sp>
+      <p:sp>
+        <p:nvSpPr>
+          <p:cNvPr id="11" name="Rounded Rectangle 10"/>
+          <p:cNvSpPr/>
+          <p:nvPr/>
+        </p:nvSpPr>
+        <p:spPr>
+          <a:xfrm>
+            <a:off x="7560000" y="4492500"/>
+            <a:ext cx="4129080" cy="827500"/>
+          </a:xfrm>
+          <a:prstGeom prst="roundRect">
+            <a:avLst>
+              <a:gd name="adj" fmla="val 9000"/>
+            </a:avLst>
+          </a:prstGeom>
+          <a:solidFill>
+            <a:srgbClr val="F5F8FC"/>
+          </a:solidFill>
+          <a:ln w="12700">
+            <a:solidFill>
+              <a:srgbClr val="DCE4EE"/>
+            </a:solidFill>
+          </a:ln>
+          <a:effectLst/>
+        </p:spPr>
+        <p:style>
+          <a:lnRef idx="1">
+            <a:schemeClr val="accent1"/>
+          </a:lnRef>
+          <a:fillRef idx="3">
+            <a:schemeClr val="accent1"/>
+          </a:fillRef>
+          <a:effectRef idx="2">
+            <a:schemeClr val="accent1"/>
+          </a:effectRef>
+          <a:fontRef idx="minor">
+            <a:schemeClr val="lt1"/>
+          </a:fontRef>
+        </p:style>
+        <p:txBody>
+          <a:bodyPr rtlCol="0" anchor="ctr"/>
+          <a:lstStyle/>
+          <a:p>
+            <a:pPr algn="ctr"/>
+          </a:p>
+        </p:txBody>
+      </p:sp>
+      <p:sp>
+        <p:nvSpPr>
+          <p:cNvPr id="12" name="TextBox 11"/>
+          <p:cNvSpPr txBox="1"/>
+          <p:nvPr/>
+        </p:nvSpPr>
+        <p:spPr>
+          <a:xfrm>
+            <a:off x="7720000" y="4547500"/>
+            <a:ext cx="3809080" cy="717500"/>
+          </a:xfrm>
+          <a:prstGeom prst="rect">
+            <a:avLst/>
+          </a:prstGeom>
+          <a:noFill/>
+        </p:spPr>
+        <p:txBody>
+          <a:bodyPr wrap="square" lIns="0" rIns="0" tIns="0" bIns="0" anchor="t">
+            <a:spAutoFit/>
+          </a:bodyPr>
+          <a:lstStyle/>
+          <a:p>
+            <a:r>
+              <a:rPr sz="1300" b="1" i="0">
+                <a:solidFill>
+                  <a:srgbClr val="C0392B"/>
+                </a:solidFill>
+                <a:latin typeface="Cambria"/>
+              </a:rPr>
+              <a:t>Parcial restabelece</a:t>
+            </a:r>
+          </a:p>
+          <a:p>
+            <a:r>
+              <a:rPr sz="1050" b="0" i="0">
+                <a:solidFill>
+                  <a:srgbClr val="5B6B82"/>
+                </a:solidFill>
+                <a:latin typeface="Calibri"/>
+              </a:rPr>
+              <a:t>liberando “Sonolento” (fadiga_3) e vigor_4, o viés cai 0,135→0,064 — quebra local, não global.</a:t>
+            </a:r>
+          </a:p>
+        </p:txBody>
+      </p:sp>
+      <p:sp>
+        <p:nvSpPr>
+          <p:cNvPr id="13" name="Rounded Rectangle 12"/>
+          <p:cNvSpPr/>
+          <p:nvPr/>
+        </p:nvSpPr>
+        <p:spPr>
+          <a:xfrm>
+            <a:off x="548640" y="5560000"/>
+            <a:ext cx="11094720" cy="700000"/>
+          </a:xfrm>
+          <a:prstGeom prst="roundRect">
+            <a:avLst>
+              <a:gd name="adj" fmla="val 12000"/>
+            </a:avLst>
+          </a:prstGeom>
+          <a:solidFill>
+            <a:srgbClr val="F5F8FC"/>
+          </a:solidFill>
+          <a:ln w="12700">
+            <a:solidFill>
+              <a:srgbClr val="DCE4EE"/>
+            </a:solidFill>
+          </a:ln>
+          <a:effectLst/>
+        </p:spPr>
+        <p:style>
+          <a:lnRef idx="1">
+            <a:schemeClr val="accent1"/>
+          </a:lnRef>
+          <a:fillRef idx="3">
+            <a:schemeClr val="accent1"/>
+          </a:fillRef>
+          <a:effectRef idx="2">
+            <a:schemeClr val="accent1"/>
+          </a:effectRef>
+          <a:fontRef idx="minor">
+            <a:schemeClr val="lt1"/>
+          </a:fontRef>
+        </p:style>
+        <p:txBody>
+          <a:bodyPr rtlCol="0" anchor="ctr"/>
+          <a:lstStyle/>
+          <a:p>
+            <a:pPr algn="ctr"/>
+          </a:p>
+        </p:txBody>
+      </p:sp>
+      <p:sp>
+        <p:nvSpPr>
+          <p:cNvPr id="14" name="TextBox 13"/>
+          <p:cNvSpPr txBox="1"/>
+          <p:nvPr/>
+        </p:nvSpPr>
+        <p:spPr>
+          <a:xfrm>
+            <a:off x="777240" y="5560000"/>
+            <a:ext cx="10644720" cy="700000"/>
+          </a:xfrm>
+          <a:prstGeom prst="rect">
+            <a:avLst/>
+          </a:prstGeom>
+          <a:noFill/>
+        </p:spPr>
+        <p:txBody>
+          <a:bodyPr wrap="square" lIns="0" rIns="0" tIns="0" bIns="0" anchor="ctr">
+            <a:spAutoFit/>
+          </a:bodyPr>
+          <a:lstStyle/>
+          <a:p>
+            <a:r>
+              <a:rPr sz="1300" b="1" i="0">
+                <a:solidFill>
+                  <a:srgbClr val="C7871B"/>
+                </a:solidFill>
+                <a:latin typeface="Calibri"/>
+              </a:rPr>
+              <a:t>▸  </a:t>
+            </a:r>
+            <a:r>
+              <a:rPr sz="1300" b="1" i="0">
+                <a:solidFill>
+                  <a:srgbClr val="14243A"/>
+                </a:solidFill>
+                <a:latin typeface="Calibri"/>
+              </a:rPr>
+              <a:t>A mudança pré→pós é um deslocamento de estado, não artefato de medida: a invariância se sustenta e a quebra é local e identificada.</a:t>
+            </a:r>
+          </a:p>
+        </p:txBody>
+      </p:sp>
+      <p:sp>
+        <p:nvSpPr>
+          <p:cNvPr id="15" name="TextBox 14"/>
+          <p:cNvSpPr txBox="1"/>
+          <p:nvPr/>
+        </p:nvSpPr>
+        <p:spPr>
+          <a:xfrm>
+            <a:off x="457200" y="6473952"/>
+            <a:ext cx="9000000" cy="274320"/>
+          </a:xfrm>
+          <a:prstGeom prst="rect">
+            <a:avLst/>
+          </a:prstGeom>
+          <a:noFill/>
+        </p:spPr>
+        <p:txBody>
+          <a:bodyPr wrap="square" lIns="0" rIns="0" tIns="0" bIns="0" anchor="ctr">
+            <a:spAutoFit/>
+          </a:bodyPr>
+          <a:lstStyle/>
+          <a:p>
+            <a:r>
+              <a:rPr sz="900" b="0" i="0">
+                <a:solidFill>
+                  <a:srgbClr val="93A1B5"/>
+                </a:solidFill>
+                <a:latin typeface="Calibri"/>
+              </a:rPr>
+              <a:t>BRUMS × HIIT · síntese analítica</a:t>
+            </a:r>
+          </a:p>
+        </p:txBody>
+      </p:sp>
+      <p:sp>
+        <p:nvSpPr>
+          <p:cNvPr id="16" name="TextBox 15"/>
+          <p:cNvSpPr txBox="1"/>
+          <p:nvPr/>
+        </p:nvSpPr>
+        <p:spPr>
+          <a:xfrm>
+            <a:off x="11247120" y="6473952"/>
+            <a:ext cx="548640" cy="274320"/>
+          </a:xfrm>
+          <a:prstGeom prst="rect">
+            <a:avLst/>
+          </a:prstGeom>
+          <a:noFill/>
+        </p:spPr>
+        <p:txBody>
+          <a:bodyPr wrap="square" lIns="0" rIns="0" tIns="0" bIns="0" anchor="ctr">
+            <a:spAutoFit/>
+          </a:bodyPr>
+          <a:lstStyle/>
+          <a:p>
+            <a:pPr algn="r"/>
+            <a:r>
+              <a:rPr sz="900" b="0" i="0">
+                <a:solidFill>
+                  <a:srgbClr val="93A1B5"/>
+                </a:solidFill>
+                <a:latin typeface="Calibri"/>
+              </a:rPr>
+              <a:t>27</a:t>
+            </a:r>
+          </a:p>
+        </p:txBody>
+      </p:sp>
+    </p:spTree>
+  </p:cSld>
+  <p:clrMapOvr>
+    <a:masterClrMapping/>
+  </p:clrMapOvr>
+</p:sld>
+</file>
+
+<file path=ppt/slides/slide28.xml><?xml version="1.0" encoding="utf-8"?>
+<p:sld xmlns:a="http://schemas.openxmlformats.org/drawingml/2006/main" xmlns:p="http://schemas.openxmlformats.org/presentationml/2006/main" xmlns:r="http://schemas.openxmlformats.org/officeDocument/2006/relationships">
+  <p:cSld>
+    <p:spTree>
+      <p:nvGrpSpPr>
+        <p:cNvPr id="1" name=""/>
+        <p:cNvGrpSpPr/>
+        <p:nvPr/>
+      </p:nvGrpSpPr>
+      <p:grpSpPr/>
+      <p:sp>
+        <p:nvSpPr>
+          <p:cNvPr id="2" name="TextBox 1"/>
+          <p:cNvSpPr txBox="1"/>
+          <p:nvPr/>
+        </p:nvSpPr>
+        <p:spPr>
+          <a:xfrm>
+            <a:off x="502920" y="384048"/>
+            <a:ext cx="10972800" cy="292608"/>
+          </a:xfrm>
+          <a:prstGeom prst="rect">
+            <a:avLst/>
+          </a:prstGeom>
+          <a:noFill/>
+        </p:spPr>
+        <p:txBody>
+          <a:bodyPr wrap="square" lIns="0" rIns="0" tIns="0" bIns="0" anchor="ctr">
+            <a:spAutoFit/>
+          </a:bodyPr>
+          <a:lstStyle/>
+          <a:p>
+            <a:r>
+              <a:rPr sz="1200" b="1" i="0" spc="200">
+                <a:solidFill>
+                  <a:srgbClr val="0E8C86"/>
+                </a:solidFill>
+                <a:latin typeface="Calibri"/>
+              </a:rPr>
+              <a:t>RESULTADOS · CARGA × HUMOR E PREDITORES</a:t>
+            </a:r>
+          </a:p>
+        </p:txBody>
+      </p:sp>
+      <p:sp>
+        <p:nvSpPr>
+          <p:cNvPr id="3" name="TextBox 2"/>
+          <p:cNvSpPr txBox="1"/>
+          <p:nvPr/>
+        </p:nvSpPr>
+        <p:spPr>
+          <a:xfrm>
+            <a:off x="457200" y="676656"/>
+            <a:ext cx="11247120" cy="860000"/>
+          </a:xfrm>
+          <a:prstGeom prst="rect">
+            <a:avLst/>
+          </a:prstGeom>
+          <a:noFill/>
+        </p:spPr>
+        <p:txBody>
+          <a:bodyPr wrap="square" lIns="0" rIns="0" tIns="0" bIns="0" anchor="ctr">
+            <a:spAutoFit/>
+          </a:bodyPr>
+          <a:lstStyle/>
+          <a:p>
+            <a:r>
+              <a:rPr sz="2600" b="1" i="0">
+                <a:solidFill>
+                  <a:srgbClr val="14243A"/>
+                </a:solidFill>
+                <a:latin typeface="Cambria"/>
+              </a:rPr>
+              <a:t>Carga interna × humor e preditores de estado de fadiga</a:t>
+            </a:r>
+          </a:p>
+        </p:txBody>
+      </p:sp>
+      <p:pic>
+        <p:nvPicPr>
+          <p:cNvPr id="4" name="Picture 3" descr="carga_humor_fig.png"/>
+          <p:cNvPicPr>
+            <a:picLocks noChangeAspect="1"/>
+          </p:cNvPicPr>
+          <p:nvPr/>
+        </p:nvPicPr>
+        <p:blipFill>
+          <a:blip r:embed="rId2"/>
+          <a:stretch>
+            <a:fillRect/>
+          </a:stretch>
+        </p:blipFill>
+        <p:spPr>
+          <a:xfrm>
+            <a:off x="502920" y="1916079"/>
+            <a:ext cx="6850000" cy="3047842"/>
+          </a:xfrm>
+          <a:prstGeom prst="rect">
+            <a:avLst/>
+          </a:prstGeom>
+        </p:spPr>
+      </p:pic>
+      <p:sp>
+        <p:nvSpPr>
+          <p:cNvPr id="5" name="Rounded Rectangle 4"/>
+          <p:cNvSpPr/>
+          <p:nvPr/>
+        </p:nvSpPr>
+        <p:spPr>
+          <a:xfrm>
+            <a:off x="7560000" y="1560000"/>
+            <a:ext cx="4129080" cy="827500"/>
+          </a:xfrm>
+          <a:prstGeom prst="roundRect">
+            <a:avLst>
+              <a:gd name="adj" fmla="val 9000"/>
+            </a:avLst>
+          </a:prstGeom>
+          <a:solidFill>
+            <a:srgbClr val="F5F8FC"/>
+          </a:solidFill>
+          <a:ln w="12700">
+            <a:solidFill>
+              <a:srgbClr val="DCE4EE"/>
+            </a:solidFill>
+          </a:ln>
+          <a:effectLst/>
+        </p:spPr>
+        <p:style>
+          <a:lnRef idx="1">
+            <a:schemeClr val="accent1"/>
+          </a:lnRef>
+          <a:fillRef idx="3">
+            <a:schemeClr val="accent1"/>
+          </a:fillRef>
+          <a:effectRef idx="2">
+            <a:schemeClr val="accent1"/>
+          </a:effectRef>
+          <a:fontRef idx="minor">
+            <a:schemeClr val="lt1"/>
+          </a:fontRef>
+        </p:style>
+        <p:txBody>
+          <a:bodyPr rtlCol="0" anchor="ctr"/>
+          <a:lstStyle/>
+          <a:p>
+            <a:pPr algn="ctr"/>
+          </a:p>
+        </p:txBody>
+      </p:sp>
+      <p:sp>
+        <p:nvSpPr>
+          <p:cNvPr id="6" name="TextBox 5"/>
+          <p:cNvSpPr txBox="1"/>
+          <p:nvPr/>
+        </p:nvSpPr>
+        <p:spPr>
+          <a:xfrm>
+            <a:off x="7720000" y="1615000"/>
+            <a:ext cx="3809080" cy="717500"/>
+          </a:xfrm>
+          <a:prstGeom prst="rect">
+            <a:avLst/>
+          </a:prstGeom>
+          <a:noFill/>
+        </p:spPr>
+        <p:txBody>
+          <a:bodyPr wrap="square" lIns="0" rIns="0" tIns="0" bIns="0" anchor="t">
+            <a:spAutoFit/>
+          </a:bodyPr>
+          <a:lstStyle/>
+          <a:p>
+            <a:r>
+              <a:rPr sz="1300" b="1" i="0">
+                <a:solidFill>
+                  <a:srgbClr val="245C8B"/>
+                </a:solidFill>
+                <a:latin typeface="Cambria"/>
+              </a:rPr>
+              <a:t>Desacoplamento</a:t>
+            </a:r>
+          </a:p>
+          <a:p>
+            <a:r>
+              <a:rPr sz="1050" b="0" i="0">
+                <a:solidFill>
+                  <a:srgbClr val="5B6B82"/>
+                </a:solidFill>
+                <a:latin typeface="Calibri"/>
+              </a:rPr>
+              <a:t>PSE/FC/TRIMP × humor: nada sobrevive à FDR — a carga prescreve o estímulo, não a resposta.</a:t>
+            </a:r>
+          </a:p>
+        </p:txBody>
+      </p:sp>
+      <p:sp>
+        <p:nvSpPr>
+          <p:cNvPr id="7" name="Rounded Rectangle 6"/>
+          <p:cNvSpPr/>
+          <p:nvPr/>
+        </p:nvSpPr>
+        <p:spPr>
+          <a:xfrm>
+            <a:off x="7560000" y="2537500"/>
+            <a:ext cx="4129080" cy="827500"/>
+          </a:xfrm>
+          <a:prstGeom prst="roundRect">
+            <a:avLst>
+              <a:gd name="adj" fmla="val 9000"/>
+            </a:avLst>
+          </a:prstGeom>
+          <a:solidFill>
+            <a:srgbClr val="F5F8FC"/>
+          </a:solidFill>
+          <a:ln w="12700">
+            <a:solidFill>
+              <a:srgbClr val="DCE4EE"/>
+            </a:solidFill>
+          </a:ln>
+          <a:effectLst/>
+        </p:spPr>
+        <p:style>
+          <a:lnRef idx="1">
+            <a:schemeClr val="accent1"/>
+          </a:lnRef>
+          <a:fillRef idx="3">
+            <a:schemeClr val="accent1"/>
+          </a:fillRef>
+          <a:effectRef idx="2">
+            <a:schemeClr val="accent1"/>
+          </a:effectRef>
+          <a:fontRef idx="minor">
+            <a:schemeClr val="lt1"/>
+          </a:fontRef>
+        </p:style>
+        <p:txBody>
+          <a:bodyPr rtlCol="0" anchor="ctr"/>
+          <a:lstStyle/>
+          <a:p>
+            <a:pPr algn="ctr"/>
+          </a:p>
+        </p:txBody>
+      </p:sp>
+      <p:sp>
+        <p:nvSpPr>
+          <p:cNvPr id="8" name="TextBox 7"/>
+          <p:cNvSpPr txBox="1"/>
+          <p:nvPr/>
+        </p:nvSpPr>
+        <p:spPr>
+          <a:xfrm>
+            <a:off x="7720000" y="2592500"/>
+            <a:ext cx="3809080" cy="717500"/>
+          </a:xfrm>
+          <a:prstGeom prst="rect">
+            <a:avLst/>
+          </a:prstGeom>
+          <a:noFill/>
+        </p:spPr>
+        <p:txBody>
+          <a:bodyPr wrap="square" lIns="0" rIns="0" tIns="0" bIns="0" anchor="t">
+            <a:spAutoFit/>
+          </a:bodyPr>
+          <a:lstStyle/>
+          <a:p>
+            <a:r>
+              <a:rPr sz="1300" b="1" i="0">
+                <a:solidFill>
+                  <a:srgbClr val="C0392B"/>
+                </a:solidFill>
+                <a:latin typeface="Cambria"/>
+              </a:rPr>
+              <a:t>Mais sensível</a:t>
+            </a:r>
+          </a:p>
+          <a:p>
+            <a:r>
+              <a:rPr sz="1050" b="0" i="0">
+                <a:solidFill>
+                  <a:srgbClr val="5B6B82"/>
+                </a:solidFill>
+                <a:latin typeface="Calibri"/>
+              </a:rPr>
+              <a:t>fadiga física: AUC 0,90 (estado-lábil, ICC 0,28) — a melhor sentinela de estado.</a:t>
+            </a:r>
+          </a:p>
+        </p:txBody>
+      </p:sp>
+      <p:sp>
+        <p:nvSpPr>
+          <p:cNvPr id="9" name="Rounded Rectangle 8"/>
+          <p:cNvSpPr/>
+          <p:nvPr/>
+        </p:nvSpPr>
+        <p:spPr>
+          <a:xfrm>
+            <a:off x="7560000" y="3515000"/>
+            <a:ext cx="4129080" cy="827500"/>
+          </a:xfrm>
+          <a:prstGeom prst="roundRect">
+            <a:avLst>
+              <a:gd name="adj" fmla="val 9000"/>
+            </a:avLst>
+          </a:prstGeom>
+          <a:solidFill>
+            <a:srgbClr val="F5F8FC"/>
+          </a:solidFill>
+          <a:ln w="12700">
+            <a:solidFill>
+              <a:srgbClr val="DCE4EE"/>
+            </a:solidFill>
+          </a:ln>
+          <a:effectLst/>
+        </p:spPr>
+        <p:style>
+          <a:lnRef idx="1">
+            <a:schemeClr val="accent1"/>
+          </a:lnRef>
+          <a:fillRef idx="3">
+            <a:schemeClr val="accent1"/>
+          </a:fillRef>
+          <a:effectRef idx="2">
+            <a:schemeClr val="accent1"/>
+          </a:effectRef>
+          <a:fontRef idx="minor">
+            <a:schemeClr val="lt1"/>
+          </a:fontRef>
+        </p:style>
+        <p:txBody>
+          <a:bodyPr rtlCol="0" anchor="ctr"/>
+          <a:lstStyle/>
+          <a:p>
+            <a:pPr algn="ctr"/>
+          </a:p>
+        </p:txBody>
+      </p:sp>
+      <p:sp>
+        <p:nvSpPr>
+          <p:cNvPr id="10" name="TextBox 9"/>
+          <p:cNvSpPr txBox="1"/>
+          <p:nvPr/>
+        </p:nvSpPr>
+        <p:spPr>
+          <a:xfrm>
+            <a:off x="7720000" y="3570000"/>
+            <a:ext cx="3809080" cy="717500"/>
+          </a:xfrm>
+          <a:prstGeom prst="rect">
+            <a:avLst/>
+          </a:prstGeom>
+          <a:noFill/>
+        </p:spPr>
+        <p:txBody>
+          <a:bodyPr wrap="square" lIns="0" rIns="0" tIns="0" bIns="0" anchor="t">
+            <a:spAutoFit/>
+          </a:bodyPr>
+          <a:lstStyle/>
+          <a:p>
+            <a:r>
+              <a:rPr sz="1300" b="1" i="0">
+                <a:solidFill>
+                  <a:srgbClr val="2E7D5B"/>
+                </a:solidFill>
+                <a:latin typeface="Cambria"/>
+              </a:rPr>
+              <a:t>Sensível E confiável</a:t>
+            </a:r>
+          </a:p>
+          <a:p>
+            <a:r>
+              <a:rPr sz="1050" b="0" i="0">
+                <a:solidFill>
+                  <a:srgbClr val="5B6B82"/>
+                </a:solidFill>
+                <a:latin typeface="Calibri"/>
+              </a:rPr>
+              <a:t>fadiga mental (ICC 0,72) e depressão (ICC 0,79) — marcadores estáveis dia a dia.</a:t>
+            </a:r>
+          </a:p>
+        </p:txBody>
+      </p:sp>
+      <p:sp>
+        <p:nvSpPr>
+          <p:cNvPr id="11" name="Rounded Rectangle 10"/>
+          <p:cNvSpPr/>
+          <p:nvPr/>
+        </p:nvSpPr>
+        <p:spPr>
+          <a:xfrm>
+            <a:off x="7560000" y="4492500"/>
+            <a:ext cx="4129080" cy="827500"/>
+          </a:xfrm>
+          <a:prstGeom prst="roundRect">
+            <a:avLst>
+              <a:gd name="adj" fmla="val 9000"/>
+            </a:avLst>
+          </a:prstGeom>
+          <a:solidFill>
+            <a:srgbClr val="F5F8FC"/>
+          </a:solidFill>
+          <a:ln w="12700">
+            <a:solidFill>
+              <a:srgbClr val="DCE4EE"/>
+            </a:solidFill>
+          </a:ln>
+          <a:effectLst/>
+        </p:spPr>
+        <p:style>
+          <a:lnRef idx="1">
+            <a:schemeClr val="accent1"/>
+          </a:lnRef>
+          <a:fillRef idx="3">
+            <a:schemeClr val="accent1"/>
+          </a:fillRef>
+          <a:effectRef idx="2">
+            <a:schemeClr val="accent1"/>
+          </a:effectRef>
+          <a:fontRef idx="minor">
+            <a:schemeClr val="lt1"/>
+          </a:fontRef>
+        </p:style>
+        <p:txBody>
+          <a:bodyPr rtlCol="0" anchor="ctr"/>
+          <a:lstStyle/>
+          <a:p>
+            <a:pPr algn="ctr"/>
+          </a:p>
+        </p:txBody>
+      </p:sp>
+      <p:sp>
+        <p:nvSpPr>
+          <p:cNvPr id="12" name="TextBox 11"/>
+          <p:cNvSpPr txBox="1"/>
+          <p:nvPr/>
+        </p:nvSpPr>
+        <p:spPr>
+          <a:xfrm>
+            <a:off x="7720000" y="4547500"/>
+            <a:ext cx="3809080" cy="717500"/>
+          </a:xfrm>
+          <a:prstGeom prst="rect">
+            <a:avLst/>
+          </a:prstGeom>
+          <a:noFill/>
+        </p:spPr>
+        <p:txBody>
+          <a:bodyPr wrap="square" lIns="0" rIns="0" tIns="0" bIns="0" anchor="t">
+            <a:spAutoFit/>
+          </a:bodyPr>
+          <a:lstStyle/>
+          <a:p>
+            <a:r>
+              <a:rPr sz="1300" b="1" i="0">
+                <a:solidFill>
+                  <a:srgbClr val="C7871B"/>
+                </a:solidFill>
+                <a:latin typeface="Cambria"/>
+              </a:rPr>
+              <a:t>Confiável, porém cega</a:t>
+            </a:r>
+          </a:p>
+          <a:p>
+            <a:r>
+              <a:rPr sz="1050" b="0" i="0">
+                <a:solidFill>
+                  <a:srgbClr val="5B6B82"/>
+                </a:solidFill>
+                <a:latin typeface="Calibri"/>
+              </a:rPr>
+              <a:t>tensão: a mais estável (ICC 0,83), mas AUC 0,54 — não discrimina fadiga.</a:t>
+            </a:r>
+          </a:p>
+        </p:txBody>
+      </p:sp>
+      <p:sp>
+        <p:nvSpPr>
+          <p:cNvPr id="13" name="Rounded Rectangle 12"/>
+          <p:cNvSpPr/>
+          <p:nvPr/>
+        </p:nvSpPr>
+        <p:spPr>
+          <a:xfrm>
+            <a:off x="548640" y="5560000"/>
+            <a:ext cx="11094720" cy="700000"/>
+          </a:xfrm>
+          <a:prstGeom prst="roundRect">
+            <a:avLst>
+              <a:gd name="adj" fmla="val 12000"/>
+            </a:avLst>
+          </a:prstGeom>
+          <a:solidFill>
+            <a:srgbClr val="F5F8FC"/>
+          </a:solidFill>
+          <a:ln w="12700">
+            <a:solidFill>
+              <a:srgbClr val="DCE4EE"/>
+            </a:solidFill>
+          </a:ln>
+          <a:effectLst/>
+        </p:spPr>
+        <p:style>
+          <a:lnRef idx="1">
+            <a:schemeClr val="accent1"/>
+          </a:lnRef>
+          <a:fillRef idx="3">
+            <a:schemeClr val="accent1"/>
+          </a:fillRef>
+          <a:effectRef idx="2">
+            <a:schemeClr val="accent1"/>
+          </a:effectRef>
+          <a:fontRef idx="minor">
+            <a:schemeClr val="lt1"/>
+          </a:fontRef>
+        </p:style>
+        <p:txBody>
+          <a:bodyPr rtlCol="0" anchor="ctr"/>
+          <a:lstStyle/>
+          <a:p>
+            <a:pPr algn="ctr"/>
+          </a:p>
+        </p:txBody>
+      </p:sp>
+      <p:sp>
+        <p:nvSpPr>
+          <p:cNvPr id="14" name="TextBox 13"/>
+          <p:cNvSpPr txBox="1"/>
+          <p:nvPr/>
+        </p:nvSpPr>
+        <p:spPr>
+          <a:xfrm>
+            <a:off x="777240" y="5560000"/>
+            <a:ext cx="10644720" cy="700000"/>
+          </a:xfrm>
+          <a:prstGeom prst="rect">
+            <a:avLst/>
+          </a:prstGeom>
+          <a:noFill/>
+        </p:spPr>
+        <p:txBody>
+          <a:bodyPr wrap="square" lIns="0" rIns="0" tIns="0" bIns="0" anchor="ctr">
+            <a:spAutoFit/>
+          </a:bodyPr>
+          <a:lstStyle/>
+          <a:p>
+            <a:r>
+              <a:rPr sz="1300" b="1" i="0">
+                <a:solidFill>
+                  <a:srgbClr val="C7871B"/>
+                </a:solidFill>
+                <a:latin typeface="Calibri"/>
+              </a:rPr>
+              <a:t>▸  </a:t>
+            </a:r>
+            <a:r>
+              <a:rPr sz="1300" b="1" i="0">
+                <a:solidFill>
+                  <a:srgbClr val="14243A"/>
+                </a:solidFill>
+                <a:latin typeface="Calibri"/>
+              </a:rPr>
+              <a:t>Para monitorar fadiga: fadiga física pela sensibilidade; fadiga mental e depressão pela confiabilidade. Reencontra-se o eixo energia–fadiga.</a:t>
+            </a:r>
+          </a:p>
+        </p:txBody>
+      </p:sp>
+      <p:sp>
+        <p:nvSpPr>
+          <p:cNvPr id="15" name="TextBox 14"/>
+          <p:cNvSpPr txBox="1"/>
+          <p:nvPr/>
+        </p:nvSpPr>
+        <p:spPr>
+          <a:xfrm>
+            <a:off x="457200" y="6473952"/>
+            <a:ext cx="9000000" cy="274320"/>
+          </a:xfrm>
+          <a:prstGeom prst="rect">
+            <a:avLst/>
+          </a:prstGeom>
+          <a:noFill/>
+        </p:spPr>
+        <p:txBody>
+          <a:bodyPr wrap="square" lIns="0" rIns="0" tIns="0" bIns="0" anchor="ctr">
+            <a:spAutoFit/>
+          </a:bodyPr>
+          <a:lstStyle/>
+          <a:p>
+            <a:r>
+              <a:rPr sz="900" b="0" i="0">
+                <a:solidFill>
+                  <a:srgbClr val="93A1B5"/>
+                </a:solidFill>
+                <a:latin typeface="Calibri"/>
+              </a:rPr>
+              <a:t>BRUMS × HIIT · síntese analítica</a:t>
+            </a:r>
+          </a:p>
+        </p:txBody>
+      </p:sp>
+      <p:sp>
+        <p:nvSpPr>
+          <p:cNvPr id="16" name="TextBox 15"/>
+          <p:cNvSpPr txBox="1"/>
+          <p:nvPr/>
+        </p:nvSpPr>
+        <p:spPr>
+          <a:xfrm>
+            <a:off x="11247120" y="6473952"/>
+            <a:ext cx="548640" cy="274320"/>
+          </a:xfrm>
+          <a:prstGeom prst="rect">
+            <a:avLst/>
+          </a:prstGeom>
+          <a:noFill/>
+        </p:spPr>
+        <p:txBody>
+          <a:bodyPr wrap="square" lIns="0" rIns="0" tIns="0" bIns="0" anchor="ctr">
+            <a:spAutoFit/>
+          </a:bodyPr>
+          <a:lstStyle/>
+          <a:p>
+            <a:pPr algn="r"/>
+            <a:r>
+              <a:rPr sz="900" b="0" i="0">
+                <a:solidFill>
+                  <a:srgbClr val="93A1B5"/>
+                </a:solidFill>
+                <a:latin typeface="Calibri"/>
+              </a:rPr>
+              <a:t>28</a:t>
+            </a:r>
+          </a:p>
+        </p:txBody>
+      </p:sp>
+    </p:spTree>
+  </p:cSld>
+  <p:clrMapOvr>
+    <a:masterClrMapping/>
+  </p:clrMapOvr>
+</p:sld>
+</file>
+
 <file path=ppt/slides/slide3.xml><?xml version="1.0" encoding="utf-8"?>
 <p:sld xmlns:a="http://schemas.openxmlformats.org/drawingml/2006/main" xmlns:r="http://schemas.openxmlformats.org/officeDocument/2006/relationships" xmlns:p="http://schemas.openxmlformats.org/presentationml/2006/main">
   <p:cSld name="Slide 3">

</xml_diff>

<commit_message>
Inclui figuras novas (descritiva e protocolo HIIT) na apresentação e no dashboard
- Apresentação: 2 slides novos (add_novos_slides.py) — estatística descritiva
  (histogramas/box plots/dispersão/normalidade) e protocolo de HIIT
  (4×4min@104%, FC recuperação/média/máx, PSE). Deck 28→30; validação OK.
- Dashboard: figura do protocolo de HIIT na aba Monitoramento e figura de
  distribuições/normalidade na aba Descritiva (embutidas via %%FIGS%% em
  build_sinteses.py; template com window.FIGS).

Co-Authored-By: Claude Opus 4.8 <noreply@anthropic.com>
Claude-Session: https://claude.ai/code/session_0157sZ1CmW4MRSmx6a9GoYrN
</commit_message>
<xml_diff>
--- a/auditoria_brums_hiit/tese/Apresentacao_BRUMS_HIIT.pptx
+++ b/auditoria_brums_hiit/tese/Apresentacao_BRUMS_HIIT.pptx
@@ -33,6 +33,8 @@
     <p:sldId id="281" r:id="rId32"/>
     <p:sldId id="282" r:id="rId33"/>
     <p:sldId id="283" r:id="rId34"/>
+    <p:sldId id="284" r:id="rId35"/>
+    <p:sldId id="285" r:id="rId36"/>
   </p:sldIdLst>
   <p:notesMasterIdLst>
     <p:notesMasterId r:id="rId27"/>
@@ -15749,6 +15751,648 @@
 </p:sld>
 </file>
 
+<file path=ppt/slides/slide29.xml><?xml version="1.0" encoding="utf-8"?>
+<p:sld xmlns:a="http://schemas.openxmlformats.org/drawingml/2006/main" xmlns:p="http://schemas.openxmlformats.org/presentationml/2006/main" xmlns:r="http://schemas.openxmlformats.org/officeDocument/2006/relationships">
+  <p:cSld>
+    <p:spTree>
+      <p:nvGrpSpPr>
+        <p:cNvPr id="1" name=""/>
+        <p:cNvGrpSpPr/>
+        <p:nvPr/>
+      </p:nvGrpSpPr>
+      <p:grpSpPr/>
+      <p:sp>
+        <p:nvSpPr>
+          <p:cNvPr id="2" name="TextBox 1"/>
+          <p:cNvSpPr txBox="1"/>
+          <p:nvPr/>
+        </p:nvSpPr>
+        <p:spPr>
+          <a:xfrm>
+            <a:off x="502920" y="384048"/>
+            <a:ext cx="10972800" cy="292608"/>
+          </a:xfrm>
+          <a:prstGeom prst="rect">
+            <a:avLst/>
+          </a:prstGeom>
+          <a:noFill/>
+        </p:spPr>
+        <p:txBody>
+          <a:bodyPr wrap="square" lIns="0" rIns="0" tIns="0" bIns="0" anchor="ctr">
+            <a:spAutoFit/>
+          </a:bodyPr>
+          <a:lstStyle/>
+          <a:p>
+            <a:r>
+              <a:rPr sz="1200" b="1" i="0" spc="200">
+                <a:solidFill>
+                  <a:srgbClr val="0E8C86"/>
+                </a:solidFill>
+                <a:latin typeface="Calibri"/>
+              </a:rPr>
+              <a:t>RESULTADOS · ESTATÍSTICA DESCRITIVA</a:t>
+            </a:r>
+          </a:p>
+        </p:txBody>
+      </p:sp>
+      <p:sp>
+        <p:nvSpPr>
+          <p:cNvPr id="3" name="TextBox 2"/>
+          <p:cNvSpPr txBox="1"/>
+          <p:nvPr/>
+        </p:nvSpPr>
+        <p:spPr>
+          <a:xfrm>
+            <a:off x="457200" y="676656"/>
+            <a:ext cx="11247120" cy="860000"/>
+          </a:xfrm>
+          <a:prstGeom prst="rect">
+            <a:avLst/>
+          </a:prstGeom>
+          <a:noFill/>
+        </p:spPr>
+        <p:txBody>
+          <a:bodyPr wrap="square" lIns="0" rIns="0" tIns="0" bIns="0" anchor="ctr">
+            <a:spAutoFit/>
+          </a:bodyPr>
+          <a:lstStyle/>
+          <a:p>
+            <a:r>
+              <a:rPr sz="2600" b="1" i="0">
+                <a:solidFill>
+                  <a:srgbClr val="14243A"/>
+                </a:solidFill>
+                <a:latin typeface="Cambria"/>
+              </a:rPr>
+              <a:t>Estatística descritiva: distribuições e normalidade</a:t>
+            </a:r>
+          </a:p>
+        </p:txBody>
+      </p:sp>
+      <p:pic>
+        <p:nvPicPr>
+          <p:cNvPr id="4" name="Picture 3" descr="descritiva_completa_fig.png"/>
+          <p:cNvPicPr>
+            <a:picLocks noChangeAspect="1"/>
+          </p:cNvPicPr>
+          <p:nvPr/>
+        </p:nvPicPr>
+        <p:blipFill>
+          <a:blip r:embed="rId2"/>
+          <a:stretch>
+            <a:fillRect/>
+          </a:stretch>
+        </p:blipFill>
+        <p:spPr>
+          <a:xfrm>
+            <a:off x="502920" y="1560000"/>
+            <a:ext cx="5259067" cy="3760000"/>
+          </a:xfrm>
+          <a:prstGeom prst="rect">
+            <a:avLst/>
+          </a:prstGeom>
+        </p:spPr>
+      </p:pic>
+      <p:sp>
+        <p:nvSpPr>
+          <p:cNvPr id="5" name="Rounded Rectangle 4"/>
+          <p:cNvSpPr/>
+          <p:nvPr/>
+        </p:nvSpPr>
+        <p:spPr>
+          <a:xfrm>
+            <a:off x="7560000" y="1560000"/>
+            <a:ext cx="4129080" cy="827500"/>
+          </a:xfrm>
+          <a:prstGeom prst="roundRect">
+            <a:avLst>
+              <a:gd name="adj" fmla="val 9000"/>
+            </a:avLst>
+          </a:prstGeom>
+          <a:solidFill>
+            <a:srgbClr val="F5F8FC"/>
+          </a:solidFill>
+          <a:ln w="12700">
+            <a:solidFill>
+              <a:srgbClr val="DCE4EE"/>
+            </a:solidFill>
+          </a:ln>
+          <a:effectLst/>
+        </p:spPr>
+        <p:style>
+          <a:lnRef idx="1">
+            <a:schemeClr val="accent1"/>
+          </a:lnRef>
+          <a:fillRef idx="3">
+            <a:schemeClr val="accent1"/>
+          </a:fillRef>
+          <a:effectRef idx="2">
+            <a:schemeClr val="accent1"/>
+          </a:effectRef>
+          <a:fontRef idx="minor">
+            <a:schemeClr val="lt1"/>
+          </a:fontRef>
+        </p:style>
+        <p:txBody>
+          <a:bodyPr rtlCol="0" anchor="ctr"/>
+          <a:lstStyle/>
+          <a:p>
+            <a:pPr algn="ctr"/>
+          </a:p>
+        </p:txBody>
+      </p:sp>
+      <p:sp>
+        <p:nvSpPr>
+          <p:cNvPr id="6" name="TextBox 5"/>
+          <p:cNvSpPr txBox="1"/>
+          <p:nvPr/>
+        </p:nvSpPr>
+        <p:spPr>
+          <a:xfrm>
+            <a:off x="7720000" y="1615000"/>
+            <a:ext cx="3809080" cy="717500"/>
+          </a:xfrm>
+          <a:prstGeom prst="rect">
+            <a:avLst/>
+          </a:prstGeom>
+          <a:noFill/>
+        </p:spPr>
+        <p:txBody>
+          <a:bodyPr wrap="square" lIns="0" rIns="0" tIns="0" bIns="0" anchor="t">
+            <a:spAutoFit/>
+          </a:bodyPr>
+          <a:lstStyle/>
+          <a:p>
+            <a:r>
+              <a:rPr sz="1300" b="1" i="0">
+                <a:solidFill>
+                  <a:srgbClr val="245C8B"/>
+                </a:solidFill>
+                <a:latin typeface="Cambria"/>
+              </a:rPr>
+              <a:t>Histogramas</a:t>
+            </a:r>
+          </a:p>
+          <a:p>
+            <a:r>
+              <a:rPr sz="1050" b="0" i="0">
+                <a:solidFill>
+                  <a:srgbClr val="5B6B82"/>
+                </a:solidFill>
+                <a:latin typeface="Calibri"/>
+              </a:rPr>
+              <a:t>distribuição da fadiga física pré vs. pós — deslocamento à direita no pós.</a:t>
+            </a:r>
+          </a:p>
+        </p:txBody>
+      </p:sp>
+      <p:sp>
+        <p:nvSpPr>
+          <p:cNvPr id="7" name="Rounded Rectangle 6"/>
+          <p:cNvSpPr/>
+          <p:nvPr/>
+        </p:nvSpPr>
+        <p:spPr>
+          <a:xfrm>
+            <a:off x="7560000" y="2537500"/>
+            <a:ext cx="4129080" cy="827500"/>
+          </a:xfrm>
+          <a:prstGeom prst="roundRect">
+            <a:avLst>
+              <a:gd name="adj" fmla="val 9000"/>
+            </a:avLst>
+          </a:prstGeom>
+          <a:solidFill>
+            <a:srgbClr val="F5F8FC"/>
+          </a:solidFill>
+          <a:ln w="12700">
+            <a:solidFill>
+              <a:srgbClr val="DCE4EE"/>
+            </a:solidFill>
+          </a:ln>
+          <a:effectLst/>
+        </p:spPr>
+        <p:style>
+          <a:lnRef idx="1">
+            <a:schemeClr val="accent1"/>
+          </a:lnRef>
+          <a:fillRef idx="3">
+            <a:schemeClr val="accent1"/>
+          </a:fillRef>
+          <a:effectRef idx="2">
+            <a:schemeClr val="accent1"/>
+          </a:effectRef>
+          <a:fontRef idx="minor">
+            <a:schemeClr val="lt1"/>
+          </a:fontRef>
+        </p:style>
+        <p:txBody>
+          <a:bodyPr rtlCol="0" anchor="ctr"/>
+          <a:lstStyle/>
+          <a:p>
+            <a:pPr algn="ctr"/>
+          </a:p>
+        </p:txBody>
+      </p:sp>
+      <p:sp>
+        <p:nvSpPr>
+          <p:cNvPr id="8" name="TextBox 7"/>
+          <p:cNvSpPr txBox="1"/>
+          <p:nvPr/>
+        </p:nvSpPr>
+        <p:spPr>
+          <a:xfrm>
+            <a:off x="7720000" y="2592500"/>
+            <a:ext cx="3809080" cy="717500"/>
+          </a:xfrm>
+          <a:prstGeom prst="rect">
+            <a:avLst/>
+          </a:prstGeom>
+          <a:noFill/>
+        </p:spPr>
+        <p:txBody>
+          <a:bodyPr wrap="square" lIns="0" rIns="0" tIns="0" bIns="0" anchor="t">
+            <a:spAutoFit/>
+          </a:bodyPr>
+          <a:lstStyle/>
+          <a:p>
+            <a:r>
+              <a:rPr sz="1300" b="1" i="0">
+                <a:solidFill>
+                  <a:srgbClr val="C0392B"/>
+                </a:solidFill>
+                <a:latin typeface="Cambria"/>
+              </a:rPr>
+              <a:t>Box plots</a:t>
+            </a:r>
+          </a:p>
+          <a:p>
+            <a:r>
+              <a:rPr sz="1050" b="0" i="0">
+                <a:solidFill>
+                  <a:srgbClr val="5B6B82"/>
+                </a:solidFill>
+                <a:latin typeface="Calibri"/>
+              </a:rPr>
+              <a:t>pré×pós das variáveis-chave: fadiga sobe, vigor recua (eixo energia–fadiga).</a:t>
+            </a:r>
+          </a:p>
+        </p:txBody>
+      </p:sp>
+      <p:sp>
+        <p:nvSpPr>
+          <p:cNvPr id="9" name="Rounded Rectangle 8"/>
+          <p:cNvSpPr/>
+          <p:nvPr/>
+        </p:nvSpPr>
+        <p:spPr>
+          <a:xfrm>
+            <a:off x="7560000" y="3515000"/>
+            <a:ext cx="4129080" cy="827500"/>
+          </a:xfrm>
+          <a:prstGeom prst="roundRect">
+            <a:avLst>
+              <a:gd name="adj" fmla="val 9000"/>
+            </a:avLst>
+          </a:prstGeom>
+          <a:solidFill>
+            <a:srgbClr val="F5F8FC"/>
+          </a:solidFill>
+          <a:ln w="12700">
+            <a:solidFill>
+              <a:srgbClr val="DCE4EE"/>
+            </a:solidFill>
+          </a:ln>
+          <a:effectLst/>
+        </p:spPr>
+        <p:style>
+          <a:lnRef idx="1">
+            <a:schemeClr val="accent1"/>
+          </a:lnRef>
+          <a:fillRef idx="3">
+            <a:schemeClr val="accent1"/>
+          </a:fillRef>
+          <a:effectRef idx="2">
+            <a:schemeClr val="accent1"/>
+          </a:effectRef>
+          <a:fontRef idx="minor">
+            <a:schemeClr val="lt1"/>
+          </a:fontRef>
+        </p:style>
+        <p:txBody>
+          <a:bodyPr rtlCol="0" anchor="ctr"/>
+          <a:lstStyle/>
+          <a:p>
+            <a:pPr algn="ctr"/>
+          </a:p>
+        </p:txBody>
+      </p:sp>
+      <p:sp>
+        <p:nvSpPr>
+          <p:cNvPr id="10" name="TextBox 9"/>
+          <p:cNvSpPr txBox="1"/>
+          <p:nvPr/>
+        </p:nvSpPr>
+        <p:spPr>
+          <a:xfrm>
+            <a:off x="7720000" y="3570000"/>
+            <a:ext cx="3809080" cy="717500"/>
+          </a:xfrm>
+          <a:prstGeom prst="rect">
+            <a:avLst/>
+          </a:prstGeom>
+          <a:noFill/>
+        </p:spPr>
+        <p:txBody>
+          <a:bodyPr wrap="square" lIns="0" rIns="0" tIns="0" bIns="0" anchor="t">
+            <a:spAutoFit/>
+          </a:bodyPr>
+          <a:lstStyle/>
+          <a:p>
+            <a:r>
+              <a:rPr sz="1300" b="1" i="0">
+                <a:solidFill>
+                  <a:srgbClr val="2E7D5B"/>
+                </a:solidFill>
+                <a:latin typeface="Cambria"/>
+              </a:rPr>
+              <a:t>Dispersão</a:t>
+            </a:r>
+          </a:p>
+          <a:p>
+            <a:r>
+              <a:rPr sz="1050" b="0" i="0">
+                <a:solidFill>
+                  <a:srgbClr val="5B6B82"/>
+                </a:solidFill>
+                <a:latin typeface="Calibri"/>
+              </a:rPr>
+              <a:t>vigor × fadiga com r≈−0,44 — a relação inversa que define o eixo.</a:t>
+            </a:r>
+          </a:p>
+        </p:txBody>
+      </p:sp>
+      <p:sp>
+        <p:nvSpPr>
+          <p:cNvPr id="11" name="Rounded Rectangle 10"/>
+          <p:cNvSpPr/>
+          <p:nvPr/>
+        </p:nvSpPr>
+        <p:spPr>
+          <a:xfrm>
+            <a:off x="7560000" y="4492500"/>
+            <a:ext cx="4129080" cy="827500"/>
+          </a:xfrm>
+          <a:prstGeom prst="roundRect">
+            <a:avLst>
+              <a:gd name="adj" fmla="val 9000"/>
+            </a:avLst>
+          </a:prstGeom>
+          <a:solidFill>
+            <a:srgbClr val="F5F8FC"/>
+          </a:solidFill>
+          <a:ln w="12700">
+            <a:solidFill>
+              <a:srgbClr val="DCE4EE"/>
+            </a:solidFill>
+          </a:ln>
+          <a:effectLst/>
+        </p:spPr>
+        <p:style>
+          <a:lnRef idx="1">
+            <a:schemeClr val="accent1"/>
+          </a:lnRef>
+          <a:fillRef idx="3">
+            <a:schemeClr val="accent1"/>
+          </a:fillRef>
+          <a:effectRef idx="2">
+            <a:schemeClr val="accent1"/>
+          </a:effectRef>
+          <a:fontRef idx="minor">
+            <a:schemeClr val="lt1"/>
+          </a:fontRef>
+        </p:style>
+        <p:txBody>
+          <a:bodyPr rtlCol="0" anchor="ctr"/>
+          <a:lstStyle/>
+          <a:p>
+            <a:pPr algn="ctr"/>
+          </a:p>
+        </p:txBody>
+      </p:sp>
+      <p:sp>
+        <p:nvSpPr>
+          <p:cNvPr id="12" name="TextBox 11"/>
+          <p:cNvSpPr txBox="1"/>
+          <p:nvPr/>
+        </p:nvSpPr>
+        <p:spPr>
+          <a:xfrm>
+            <a:off x="7720000" y="4547500"/>
+            <a:ext cx="3809080" cy="717500"/>
+          </a:xfrm>
+          <a:prstGeom prst="rect">
+            <a:avLst/>
+          </a:prstGeom>
+          <a:noFill/>
+        </p:spPr>
+        <p:txBody>
+          <a:bodyPr wrap="square" lIns="0" rIns="0" tIns="0" bIns="0" anchor="t">
+            <a:spAutoFit/>
+          </a:bodyPr>
+          <a:lstStyle/>
+          <a:p>
+            <a:r>
+              <a:rPr sz="1300" b="1" i="0">
+                <a:solidFill>
+                  <a:srgbClr val="C7871B"/>
+                </a:solidFill>
+                <a:latin typeface="Cambria"/>
+              </a:rPr>
+              <a:t>Normalidade (Q–Q)</a:t>
+            </a:r>
+          </a:p>
+          <a:p>
+            <a:r>
+              <a:rPr sz="1050" b="0" i="0">
+                <a:solidFill>
+                  <a:srgbClr val="5B6B82"/>
+                </a:solidFill>
+                <a:latin typeface="Calibri"/>
+              </a:rPr>
+              <a:t>desvios da normal no pré e no pós (Shapiro–Wilk) — justifica permutação.</a:t>
+            </a:r>
+          </a:p>
+        </p:txBody>
+      </p:sp>
+      <p:sp>
+        <p:nvSpPr>
+          <p:cNvPr id="13" name="Rounded Rectangle 12"/>
+          <p:cNvSpPr/>
+          <p:nvPr/>
+        </p:nvSpPr>
+        <p:spPr>
+          <a:xfrm>
+            <a:off x="548640" y="5560000"/>
+            <a:ext cx="11094720" cy="700000"/>
+          </a:xfrm>
+          <a:prstGeom prst="roundRect">
+            <a:avLst>
+              <a:gd name="adj" fmla="val 12000"/>
+            </a:avLst>
+          </a:prstGeom>
+          <a:solidFill>
+            <a:srgbClr val="F5F8FC"/>
+          </a:solidFill>
+          <a:ln w="12700">
+            <a:solidFill>
+              <a:srgbClr val="DCE4EE"/>
+            </a:solidFill>
+          </a:ln>
+          <a:effectLst/>
+        </p:spPr>
+        <p:style>
+          <a:lnRef idx="1">
+            <a:schemeClr val="accent1"/>
+          </a:lnRef>
+          <a:fillRef idx="3">
+            <a:schemeClr val="accent1"/>
+          </a:fillRef>
+          <a:effectRef idx="2">
+            <a:schemeClr val="accent1"/>
+          </a:effectRef>
+          <a:fontRef idx="minor">
+            <a:schemeClr val="lt1"/>
+          </a:fontRef>
+        </p:style>
+        <p:txBody>
+          <a:bodyPr rtlCol="0" anchor="ctr"/>
+          <a:lstStyle/>
+          <a:p>
+            <a:pPr algn="ctr"/>
+          </a:p>
+        </p:txBody>
+      </p:sp>
+      <p:sp>
+        <p:nvSpPr>
+          <p:cNvPr id="14" name="TextBox 13"/>
+          <p:cNvSpPr txBox="1"/>
+          <p:nvPr/>
+        </p:nvSpPr>
+        <p:spPr>
+          <a:xfrm>
+            <a:off x="777240" y="5560000"/>
+            <a:ext cx="10644720" cy="700000"/>
+          </a:xfrm>
+          <a:prstGeom prst="rect">
+            <a:avLst/>
+          </a:prstGeom>
+          <a:noFill/>
+        </p:spPr>
+        <p:txBody>
+          <a:bodyPr wrap="square" lIns="0" rIns="0" tIns="0" bIns="0" anchor="ctr">
+            <a:spAutoFit/>
+          </a:bodyPr>
+          <a:lstStyle/>
+          <a:p>
+            <a:r>
+              <a:rPr sz="1300" b="1" i="0">
+                <a:solidFill>
+                  <a:srgbClr val="C7871B"/>
+                </a:solidFill>
+                <a:latin typeface="Calibri"/>
+              </a:rPr>
+              <a:t>▸  </a:t>
+            </a:r>
+            <a:r>
+              <a:rPr sz="1300" b="1" i="0">
+                <a:solidFill>
+                  <a:srgbClr val="14243A"/>
+                </a:solidFill>
+                <a:latin typeface="Calibri"/>
+              </a:rPr>
+              <a:t>Distribuições assimétricas e não-normais (efeito piso nas negativas): as decisões são confirmadas por testes não-paramétricos e permutação.</a:t>
+            </a:r>
+          </a:p>
+        </p:txBody>
+      </p:sp>
+      <p:sp>
+        <p:nvSpPr>
+          <p:cNvPr id="15" name="TextBox 14"/>
+          <p:cNvSpPr txBox="1"/>
+          <p:nvPr/>
+        </p:nvSpPr>
+        <p:spPr>
+          <a:xfrm>
+            <a:off x="457200" y="6473952"/>
+            <a:ext cx="9000000" cy="274320"/>
+          </a:xfrm>
+          <a:prstGeom prst="rect">
+            <a:avLst/>
+          </a:prstGeom>
+          <a:noFill/>
+        </p:spPr>
+        <p:txBody>
+          <a:bodyPr wrap="square" lIns="0" rIns="0" tIns="0" bIns="0" anchor="ctr">
+            <a:spAutoFit/>
+          </a:bodyPr>
+          <a:lstStyle/>
+          <a:p>
+            <a:r>
+              <a:rPr sz="900" b="0" i="0">
+                <a:solidFill>
+                  <a:srgbClr val="93A1B5"/>
+                </a:solidFill>
+                <a:latin typeface="Calibri"/>
+              </a:rPr>
+              <a:t>BRUMS × HIIT · síntese analítica</a:t>
+            </a:r>
+          </a:p>
+        </p:txBody>
+      </p:sp>
+      <p:sp>
+        <p:nvSpPr>
+          <p:cNvPr id="16" name="TextBox 15"/>
+          <p:cNvSpPr txBox="1"/>
+          <p:nvPr/>
+        </p:nvSpPr>
+        <p:spPr>
+          <a:xfrm>
+            <a:off x="11247120" y="6473952"/>
+            <a:ext cx="548640" cy="274320"/>
+          </a:xfrm>
+          <a:prstGeom prst="rect">
+            <a:avLst/>
+          </a:prstGeom>
+          <a:noFill/>
+        </p:spPr>
+        <p:txBody>
+          <a:bodyPr wrap="square" lIns="0" rIns="0" tIns="0" bIns="0" anchor="ctr">
+            <a:spAutoFit/>
+          </a:bodyPr>
+          <a:lstStyle/>
+          <a:p>
+            <a:pPr algn="r"/>
+            <a:r>
+              <a:rPr sz="900" b="0" i="0">
+                <a:solidFill>
+                  <a:srgbClr val="93A1B5"/>
+                </a:solidFill>
+                <a:latin typeface="Calibri"/>
+              </a:rPr>
+              <a:t>29</a:t>
+            </a:r>
+          </a:p>
+        </p:txBody>
+      </p:sp>
+    </p:spTree>
+  </p:cSld>
+  <p:clrMapOvr>
+    <a:masterClrMapping/>
+  </p:clrMapOvr>
+</p:sld>
+</file>
+
 <file path=ppt/slides/slide3.xml><?xml version="1.0" encoding="utf-8"?>
 <p:sld xmlns:a="http://schemas.openxmlformats.org/drawingml/2006/main" xmlns:r="http://schemas.openxmlformats.org/officeDocument/2006/relationships" xmlns:p="http://schemas.openxmlformats.org/presentationml/2006/main">
   <p:cSld name="Slide 3">
@@ -16604,6 +17248,648 @@
               <a:t>3</a:t>
             </a:r>
             <a:endParaRPr lang="en-US" sz="900" dirty="0"/>
+          </a:p>
+        </p:txBody>
+      </p:sp>
+    </p:spTree>
+  </p:cSld>
+  <p:clrMapOvr>
+    <a:masterClrMapping/>
+  </p:clrMapOvr>
+</p:sld>
+</file>
+
+<file path=ppt/slides/slide30.xml><?xml version="1.0" encoding="utf-8"?>
+<p:sld xmlns:a="http://schemas.openxmlformats.org/drawingml/2006/main" xmlns:p="http://schemas.openxmlformats.org/presentationml/2006/main" xmlns:r="http://schemas.openxmlformats.org/officeDocument/2006/relationships">
+  <p:cSld>
+    <p:spTree>
+      <p:nvGrpSpPr>
+        <p:cNvPr id="1" name=""/>
+        <p:cNvGrpSpPr/>
+        <p:nvPr/>
+      </p:nvGrpSpPr>
+      <p:grpSpPr/>
+      <p:sp>
+        <p:nvSpPr>
+          <p:cNvPr id="2" name="TextBox 1"/>
+          <p:cNvSpPr txBox="1"/>
+          <p:nvPr/>
+        </p:nvSpPr>
+        <p:spPr>
+          <a:xfrm>
+            <a:off x="502920" y="384048"/>
+            <a:ext cx="10972800" cy="292608"/>
+          </a:xfrm>
+          <a:prstGeom prst="rect">
+            <a:avLst/>
+          </a:prstGeom>
+          <a:noFill/>
+        </p:spPr>
+        <p:txBody>
+          <a:bodyPr wrap="square" lIns="0" rIns="0" tIns="0" bIns="0" anchor="ctr">
+            <a:spAutoFit/>
+          </a:bodyPr>
+          <a:lstStyle/>
+          <a:p>
+            <a:r>
+              <a:rPr sz="1200" b="1" i="0" spc="200">
+                <a:solidFill>
+                  <a:srgbClr val="0E8C86"/>
+                </a:solidFill>
+                <a:latin typeface="Calibri"/>
+              </a:rPr>
+              <a:t>MÉTODO · PROTOCOLO DE HIIT</a:t>
+            </a:r>
+          </a:p>
+        </p:txBody>
+      </p:sp>
+      <p:sp>
+        <p:nvSpPr>
+          <p:cNvPr id="3" name="TextBox 2"/>
+          <p:cNvSpPr txBox="1"/>
+          <p:nvPr/>
+        </p:nvSpPr>
+        <p:spPr>
+          <a:xfrm>
+            <a:off x="457200" y="676656"/>
+            <a:ext cx="11247120" cy="860000"/>
+          </a:xfrm>
+          <a:prstGeom prst="rect">
+            <a:avLst/>
+          </a:prstGeom>
+          <a:noFill/>
+        </p:spPr>
+        <p:txBody>
+          <a:bodyPr wrap="square" lIns="0" rIns="0" tIns="0" bIns="0" anchor="ctr">
+            <a:spAutoFit/>
+          </a:bodyPr>
+          <a:lstStyle/>
+          <a:p>
+            <a:r>
+              <a:rPr sz="2600" b="1" i="0">
+                <a:solidFill>
+                  <a:srgbClr val="14243A"/>
+                </a:solidFill>
+                <a:latin typeface="Cambria"/>
+              </a:rPr>
+              <a:t>Protocolo de HIIT: 4 × 4 min a 104% da velocidade de pico</a:t>
+            </a:r>
+          </a:p>
+        </p:txBody>
+      </p:sp>
+      <p:pic>
+        <p:nvPicPr>
+          <p:cNvPr id="4" name="Picture 3" descr="hiit_protocolo_fig.png"/>
+          <p:cNvPicPr>
+            <a:picLocks noChangeAspect="1"/>
+          </p:cNvPicPr>
+          <p:nvPr/>
+        </p:nvPicPr>
+        <p:blipFill>
+          <a:blip r:embed="rId2"/>
+          <a:stretch>
+            <a:fillRect/>
+          </a:stretch>
+        </p:blipFill>
+        <p:spPr>
+          <a:xfrm>
+            <a:off x="502920" y="2094771"/>
+            <a:ext cx="6850000" cy="2690457"/>
+          </a:xfrm>
+          <a:prstGeom prst="rect">
+            <a:avLst/>
+          </a:prstGeom>
+        </p:spPr>
+      </p:pic>
+      <p:sp>
+        <p:nvSpPr>
+          <p:cNvPr id="5" name="Rounded Rectangle 4"/>
+          <p:cNvSpPr/>
+          <p:nvPr/>
+        </p:nvSpPr>
+        <p:spPr>
+          <a:xfrm>
+            <a:off x="7560000" y="1560000"/>
+            <a:ext cx="4129080" cy="827500"/>
+          </a:xfrm>
+          <a:prstGeom prst="roundRect">
+            <a:avLst>
+              <a:gd name="adj" fmla="val 9000"/>
+            </a:avLst>
+          </a:prstGeom>
+          <a:solidFill>
+            <a:srgbClr val="F5F8FC"/>
+          </a:solidFill>
+          <a:ln w="12700">
+            <a:solidFill>
+              <a:srgbClr val="DCE4EE"/>
+            </a:solidFill>
+          </a:ln>
+          <a:effectLst/>
+        </p:spPr>
+        <p:style>
+          <a:lnRef idx="1">
+            <a:schemeClr val="accent1"/>
+          </a:lnRef>
+          <a:fillRef idx="3">
+            <a:schemeClr val="accent1"/>
+          </a:fillRef>
+          <a:effectRef idx="2">
+            <a:schemeClr val="accent1"/>
+          </a:effectRef>
+          <a:fontRef idx="minor">
+            <a:schemeClr val="lt1"/>
+          </a:fontRef>
+        </p:style>
+        <p:txBody>
+          <a:bodyPr rtlCol="0" anchor="ctr"/>
+          <a:lstStyle/>
+          <a:p>
+            <a:pPr algn="ctr"/>
+          </a:p>
+        </p:txBody>
+      </p:sp>
+      <p:sp>
+        <p:nvSpPr>
+          <p:cNvPr id="6" name="TextBox 5"/>
+          <p:cNvSpPr txBox="1"/>
+          <p:nvPr/>
+        </p:nvSpPr>
+        <p:spPr>
+          <a:xfrm>
+            <a:off x="7720000" y="1615000"/>
+            <a:ext cx="3809080" cy="717500"/>
+          </a:xfrm>
+          <a:prstGeom prst="rect">
+            <a:avLst/>
+          </a:prstGeom>
+          <a:noFill/>
+        </p:spPr>
+        <p:txBody>
+          <a:bodyPr wrap="square" lIns="0" rIns="0" tIns="0" bIns="0" anchor="t">
+            <a:spAutoFit/>
+          </a:bodyPr>
+          <a:lstStyle/>
+          <a:p>
+            <a:r>
+              <a:rPr sz="1300" b="1" i="0">
+                <a:solidFill>
+                  <a:srgbClr val="245C8B"/>
+                </a:solidFill>
+                <a:latin typeface="Cambria"/>
+              </a:rPr>
+              <a:t>Estímulo</a:t>
+            </a:r>
+          </a:p>
+          <a:p>
+            <a:r>
+              <a:rPr sz="1050" b="0" i="0">
+                <a:solidFill>
+                  <a:srgbClr val="5B6B82"/>
+                </a:solidFill>
+                <a:latin typeface="Calibri"/>
+              </a:rPr>
+              <a:t>4 séries de 4 min a 104% da velocidade de pico (teste de campo), 3 min de intervalo.</a:t>
+            </a:r>
+          </a:p>
+        </p:txBody>
+      </p:sp>
+      <p:sp>
+        <p:nvSpPr>
+          <p:cNvPr id="7" name="Rounded Rectangle 6"/>
+          <p:cNvSpPr/>
+          <p:nvPr/>
+        </p:nvSpPr>
+        <p:spPr>
+          <a:xfrm>
+            <a:off x="7560000" y="2537500"/>
+            <a:ext cx="4129080" cy="827500"/>
+          </a:xfrm>
+          <a:prstGeom prst="roundRect">
+            <a:avLst>
+              <a:gd name="adj" fmla="val 9000"/>
+            </a:avLst>
+          </a:prstGeom>
+          <a:solidFill>
+            <a:srgbClr val="F5F8FC"/>
+          </a:solidFill>
+          <a:ln w="12700">
+            <a:solidFill>
+              <a:srgbClr val="DCE4EE"/>
+            </a:solidFill>
+          </a:ln>
+          <a:effectLst/>
+        </p:spPr>
+        <p:style>
+          <a:lnRef idx="1">
+            <a:schemeClr val="accent1"/>
+          </a:lnRef>
+          <a:fillRef idx="3">
+            <a:schemeClr val="accent1"/>
+          </a:fillRef>
+          <a:effectRef idx="2">
+            <a:schemeClr val="accent1"/>
+          </a:effectRef>
+          <a:fontRef idx="minor">
+            <a:schemeClr val="lt1"/>
+          </a:fontRef>
+        </p:style>
+        <p:txBody>
+          <a:bodyPr rtlCol="0" anchor="ctr"/>
+          <a:lstStyle/>
+          <a:p>
+            <a:pPr algn="ctr"/>
+          </a:p>
+        </p:txBody>
+      </p:sp>
+      <p:sp>
+        <p:nvSpPr>
+          <p:cNvPr id="8" name="TextBox 7"/>
+          <p:cNvSpPr txBox="1"/>
+          <p:nvPr/>
+        </p:nvSpPr>
+        <p:spPr>
+          <a:xfrm>
+            <a:off x="7720000" y="2592500"/>
+            <a:ext cx="3809080" cy="717500"/>
+          </a:xfrm>
+          <a:prstGeom prst="rect">
+            <a:avLst/>
+          </a:prstGeom>
+          <a:noFill/>
+        </p:spPr>
+        <p:txBody>
+          <a:bodyPr wrap="square" lIns="0" rIns="0" tIns="0" bIns="0" anchor="t">
+            <a:spAutoFit/>
+          </a:bodyPr>
+          <a:lstStyle/>
+          <a:p>
+            <a:r>
+              <a:rPr sz="1300" b="1" i="0">
+                <a:solidFill>
+                  <a:srgbClr val="C0392B"/>
+                </a:solidFill>
+                <a:latin typeface="Cambria"/>
+              </a:rPr>
+              <a:t>FC das séries</a:t>
+            </a:r>
+          </a:p>
+          <a:p>
+            <a:r>
+              <a:rPr sz="1050" b="0" i="0">
+                <a:solidFill>
+                  <a:srgbClr val="5B6B82"/>
+                </a:solidFill>
+                <a:latin typeface="Calibri"/>
+              </a:rPr>
+              <a:t>pico ~186 bpm; média das 4 séries ~179 bpm — próximo ao teto aeróbio.</a:t>
+            </a:r>
+          </a:p>
+        </p:txBody>
+      </p:sp>
+      <p:sp>
+        <p:nvSpPr>
+          <p:cNvPr id="9" name="Rounded Rectangle 8"/>
+          <p:cNvSpPr/>
+          <p:nvPr/>
+        </p:nvSpPr>
+        <p:spPr>
+          <a:xfrm>
+            <a:off x="7560000" y="3515000"/>
+            <a:ext cx="4129080" cy="827500"/>
+          </a:xfrm>
+          <a:prstGeom prst="roundRect">
+            <a:avLst>
+              <a:gd name="adj" fmla="val 9000"/>
+            </a:avLst>
+          </a:prstGeom>
+          <a:solidFill>
+            <a:srgbClr val="F5F8FC"/>
+          </a:solidFill>
+          <a:ln w="12700">
+            <a:solidFill>
+              <a:srgbClr val="DCE4EE"/>
+            </a:solidFill>
+          </a:ln>
+          <a:effectLst/>
+        </p:spPr>
+        <p:style>
+          <a:lnRef idx="1">
+            <a:schemeClr val="accent1"/>
+          </a:lnRef>
+          <a:fillRef idx="3">
+            <a:schemeClr val="accent1"/>
+          </a:fillRef>
+          <a:effectRef idx="2">
+            <a:schemeClr val="accent1"/>
+          </a:effectRef>
+          <a:fontRef idx="minor">
+            <a:schemeClr val="lt1"/>
+          </a:fontRef>
+        </p:style>
+        <p:txBody>
+          <a:bodyPr rtlCol="0" anchor="ctr"/>
+          <a:lstStyle/>
+          <a:p>
+            <a:pPr algn="ctr"/>
+          </a:p>
+        </p:txBody>
+      </p:sp>
+      <p:sp>
+        <p:nvSpPr>
+          <p:cNvPr id="10" name="TextBox 9"/>
+          <p:cNvSpPr txBox="1"/>
+          <p:nvPr/>
+        </p:nvSpPr>
+        <p:spPr>
+          <a:xfrm>
+            <a:off x="7720000" y="3570000"/>
+            <a:ext cx="3809080" cy="717500"/>
+          </a:xfrm>
+          <a:prstGeom prst="rect">
+            <a:avLst/>
+          </a:prstGeom>
+          <a:noFill/>
+        </p:spPr>
+        <p:txBody>
+          <a:bodyPr wrap="square" lIns="0" rIns="0" tIns="0" bIns="0" anchor="t">
+            <a:spAutoFit/>
+          </a:bodyPr>
+          <a:lstStyle/>
+          <a:p>
+            <a:r>
+              <a:rPr sz="1300" b="1" i="0">
+                <a:solidFill>
+                  <a:srgbClr val="2E7D5B"/>
+                </a:solidFill>
+                <a:latin typeface="Cambria"/>
+              </a:rPr>
+              <a:t>Recuperação</a:t>
+            </a:r>
+          </a:p>
+          <a:p>
+            <a:r>
+              <a:rPr sz="1050" b="0" i="0">
+                <a:solidFill>
+                  <a:srgbClr val="5B6B82"/>
+                </a:solidFill>
+                <a:latin typeface="Calibri"/>
+              </a:rPr>
+              <a:t>FC de recuperação sobe ao longo da sessão (~124 bpm): deriva/recuperação incompleta.</a:t>
+            </a:r>
+          </a:p>
+        </p:txBody>
+      </p:sp>
+      <p:sp>
+        <p:nvSpPr>
+          <p:cNvPr id="11" name="Rounded Rectangle 10"/>
+          <p:cNvSpPr/>
+          <p:nvPr/>
+        </p:nvSpPr>
+        <p:spPr>
+          <a:xfrm>
+            <a:off x="7560000" y="4492500"/>
+            <a:ext cx="4129080" cy="827500"/>
+          </a:xfrm>
+          <a:prstGeom prst="roundRect">
+            <a:avLst>
+              <a:gd name="adj" fmla="val 9000"/>
+            </a:avLst>
+          </a:prstGeom>
+          <a:solidFill>
+            <a:srgbClr val="F5F8FC"/>
+          </a:solidFill>
+          <a:ln w="12700">
+            <a:solidFill>
+              <a:srgbClr val="DCE4EE"/>
+            </a:solidFill>
+          </a:ln>
+          <a:effectLst/>
+        </p:spPr>
+        <p:style>
+          <a:lnRef idx="1">
+            <a:schemeClr val="accent1"/>
+          </a:lnRef>
+          <a:fillRef idx="3">
+            <a:schemeClr val="accent1"/>
+          </a:fillRef>
+          <a:effectRef idx="2">
+            <a:schemeClr val="accent1"/>
+          </a:effectRef>
+          <a:fontRef idx="minor">
+            <a:schemeClr val="lt1"/>
+          </a:fontRef>
+        </p:style>
+        <p:txBody>
+          <a:bodyPr rtlCol="0" anchor="ctr"/>
+          <a:lstStyle/>
+          <a:p>
+            <a:pPr algn="ctr"/>
+          </a:p>
+        </p:txBody>
+      </p:sp>
+      <p:sp>
+        <p:nvSpPr>
+          <p:cNvPr id="12" name="TextBox 11"/>
+          <p:cNvSpPr txBox="1"/>
+          <p:nvPr/>
+        </p:nvSpPr>
+        <p:spPr>
+          <a:xfrm>
+            <a:off x="7720000" y="4547500"/>
+            <a:ext cx="3809080" cy="717500"/>
+          </a:xfrm>
+          <a:prstGeom prst="rect">
+            <a:avLst/>
+          </a:prstGeom>
+          <a:noFill/>
+        </p:spPr>
+        <p:txBody>
+          <a:bodyPr wrap="square" lIns="0" rIns="0" tIns="0" bIns="0" anchor="t">
+            <a:spAutoFit/>
+          </a:bodyPr>
+          <a:lstStyle/>
+          <a:p>
+            <a:r>
+              <a:rPr sz="1300" b="1" i="0">
+                <a:solidFill>
+                  <a:srgbClr val="C7871B"/>
+                </a:solidFill>
+                <a:latin typeface="Cambria"/>
+              </a:rPr>
+              <a:t>PSE</a:t>
+            </a:r>
+          </a:p>
+          <a:p>
+            <a:r>
+              <a:rPr sz="1050" b="0" i="0">
+                <a:solidFill>
+                  <a:srgbClr val="5B6B82"/>
+                </a:solidFill>
+                <a:latin typeface="Calibri"/>
+              </a:rPr>
+              <a:t>esforço percebido final ~9,9 (quase o teto da escala 0–10).</a:t>
+            </a:r>
+          </a:p>
+        </p:txBody>
+      </p:sp>
+      <p:sp>
+        <p:nvSpPr>
+          <p:cNvPr id="13" name="Rounded Rectangle 12"/>
+          <p:cNvSpPr/>
+          <p:nvPr/>
+        </p:nvSpPr>
+        <p:spPr>
+          <a:xfrm>
+            <a:off x="548640" y="5560000"/>
+            <a:ext cx="11094720" cy="700000"/>
+          </a:xfrm>
+          <a:prstGeom prst="roundRect">
+            <a:avLst>
+              <a:gd name="adj" fmla="val 12000"/>
+            </a:avLst>
+          </a:prstGeom>
+          <a:solidFill>
+            <a:srgbClr val="F5F8FC"/>
+          </a:solidFill>
+          <a:ln w="12700">
+            <a:solidFill>
+              <a:srgbClr val="DCE4EE"/>
+            </a:solidFill>
+          </a:ln>
+          <a:effectLst/>
+        </p:spPr>
+        <p:style>
+          <a:lnRef idx="1">
+            <a:schemeClr val="accent1"/>
+          </a:lnRef>
+          <a:fillRef idx="3">
+            <a:schemeClr val="accent1"/>
+          </a:fillRef>
+          <a:effectRef idx="2">
+            <a:schemeClr val="accent1"/>
+          </a:effectRef>
+          <a:fontRef idx="minor">
+            <a:schemeClr val="lt1"/>
+          </a:fontRef>
+        </p:style>
+        <p:txBody>
+          <a:bodyPr rtlCol="0" anchor="ctr"/>
+          <a:lstStyle/>
+          <a:p>
+            <a:pPr algn="ctr"/>
+          </a:p>
+        </p:txBody>
+      </p:sp>
+      <p:sp>
+        <p:nvSpPr>
+          <p:cNvPr id="14" name="TextBox 13"/>
+          <p:cNvSpPr txBox="1"/>
+          <p:nvPr/>
+        </p:nvSpPr>
+        <p:spPr>
+          <a:xfrm>
+            <a:off x="777240" y="5560000"/>
+            <a:ext cx="10644720" cy="700000"/>
+          </a:xfrm>
+          <a:prstGeom prst="rect">
+            <a:avLst/>
+          </a:prstGeom>
+          <a:noFill/>
+        </p:spPr>
+        <p:txBody>
+          <a:bodyPr wrap="square" lIns="0" rIns="0" tIns="0" bIns="0" anchor="ctr">
+            <a:spAutoFit/>
+          </a:bodyPr>
+          <a:lstStyle/>
+          <a:p>
+            <a:r>
+              <a:rPr sz="1300" b="1" i="0">
+                <a:solidFill>
+                  <a:srgbClr val="C7871B"/>
+                </a:solidFill>
+                <a:latin typeface="Calibri"/>
+              </a:rPr>
+              <a:t>▸  </a:t>
+            </a:r>
+            <a:r>
+              <a:rPr sz="1300" b="1" i="0">
+                <a:solidFill>
+                  <a:srgbClr val="14243A"/>
+                </a:solidFill>
+                <a:latin typeface="Calibri"/>
+              </a:rPr>
+              <a:t>Carga interna quase-máxima e progressiva — o regime de teto explica por que a carga não prediz a resposta de humor.</a:t>
+            </a:r>
+          </a:p>
+        </p:txBody>
+      </p:sp>
+      <p:sp>
+        <p:nvSpPr>
+          <p:cNvPr id="15" name="TextBox 14"/>
+          <p:cNvSpPr txBox="1"/>
+          <p:nvPr/>
+        </p:nvSpPr>
+        <p:spPr>
+          <a:xfrm>
+            <a:off x="457200" y="6473952"/>
+            <a:ext cx="9000000" cy="274320"/>
+          </a:xfrm>
+          <a:prstGeom prst="rect">
+            <a:avLst/>
+          </a:prstGeom>
+          <a:noFill/>
+        </p:spPr>
+        <p:txBody>
+          <a:bodyPr wrap="square" lIns="0" rIns="0" tIns="0" bIns="0" anchor="ctr">
+            <a:spAutoFit/>
+          </a:bodyPr>
+          <a:lstStyle/>
+          <a:p>
+            <a:r>
+              <a:rPr sz="900" b="0" i="0">
+                <a:solidFill>
+                  <a:srgbClr val="93A1B5"/>
+                </a:solidFill>
+                <a:latin typeface="Calibri"/>
+              </a:rPr>
+              <a:t>BRUMS × HIIT · síntese analítica</a:t>
+            </a:r>
+          </a:p>
+        </p:txBody>
+      </p:sp>
+      <p:sp>
+        <p:nvSpPr>
+          <p:cNvPr id="16" name="TextBox 15"/>
+          <p:cNvSpPr txBox="1"/>
+          <p:nvPr/>
+        </p:nvSpPr>
+        <p:spPr>
+          <a:xfrm>
+            <a:off x="11247120" y="6473952"/>
+            <a:ext cx="548640" cy="274320"/>
+          </a:xfrm>
+          <a:prstGeom prst="rect">
+            <a:avLst/>
+          </a:prstGeom>
+          <a:noFill/>
+        </p:spPr>
+        <p:txBody>
+          <a:bodyPr wrap="square" lIns="0" rIns="0" tIns="0" bIns="0" anchor="ctr">
+            <a:spAutoFit/>
+          </a:bodyPr>
+          <a:lstStyle/>
+          <a:p>
+            <a:pPr algn="r"/>
+            <a:r>
+              <a:rPr sz="900" b="0" i="0">
+                <a:solidFill>
+                  <a:srgbClr val="93A1B5"/>
+                </a:solidFill>
+                <a:latin typeface="Calibri"/>
+              </a:rPr>
+              <a:t>30</a:t>
+            </a:r>
           </a:p>
         </p:txBody>
       </p:sp>

</xml_diff>